<commit_message>
:construction: Move GUI code to GUI class
Big refactor. Maybe too big.
</commit_message>
<xml_diff>
--- a/doc/bmc-system-charts.pptx
+++ b/doc/bmc-system-charts.pptx
@@ -7,9 +7,12 @@
   <p:sldIdLst>
     <p:sldId id="256" r:id="rId2"/>
     <p:sldId id="260" r:id="rId3"/>
-    <p:sldId id="257" r:id="rId4"/>
-    <p:sldId id="258" r:id="rId5"/>
-    <p:sldId id="259" r:id="rId6"/>
+    <p:sldId id="262" r:id="rId4"/>
+    <p:sldId id="263" r:id="rId5"/>
+    <p:sldId id="261" r:id="rId6"/>
+    <p:sldId id="257" r:id="rId7"/>
+    <p:sldId id="258" r:id="rId8"/>
+    <p:sldId id="259" r:id="rId9"/>
   </p:sldIdLst>
   <p:sldSz cx="12192000" cy="6858000"/>
   <p:notesSz cx="6858000" cy="9144000"/>
@@ -108,13 +111,18 @@
       </a:defRPr>
     </a:lvl9pPr>
   </p:defaultTextStyle>
+  <p:extLst>
+    <p:ext uri="{EFAFB233-063F-42B5-8137-9DF3F51BA10A}">
+      <p15:sldGuideLst xmlns:p15="http://schemas.microsoft.com/office/powerpoint/2012/main"/>
+    </p:ext>
+  </p:extLst>
 </p:presentation>
 </file>
 
 <file path=ppt/revisionInfo.xml><?xml version="1.0" encoding="utf-8"?>
 <p1510:revInfo xmlns:a="http://schemas.openxmlformats.org/drawingml/2006/main" xmlns:r="http://schemas.openxmlformats.org/officeDocument/2006/relationships" xmlns:p1510="http://schemas.microsoft.com/office/powerpoint/2015/10/main">
   <p1510:revLst>
-    <p1510:client id="{6D8F685D-64B7-49F8-B054-0F740B6185A0}" v="8" dt="2026-09-23T19:00:21.602"/>
+    <p1510:client id="{6D8F685D-64B7-49F8-B054-0F740B6185A0}" v="13" dt="2026-09-23T21:33:29.788"/>
   </p1510:revLst>
 </p1510:revInfo>
 </file>
@@ -123,13 +131,35 @@
 <pc:chgInfo xmlns:a="http://schemas.openxmlformats.org/drawingml/2006/main" xmlns:r="http://schemas.openxmlformats.org/officeDocument/2006/relationships" xmlns:ac="http://schemas.microsoft.com/office/drawing/2013/main/command" xmlns:pc="http://schemas.microsoft.com/office/powerpoint/2013/main/command">
   <pc:docChgLst>
     <pc:chgData name="Daniel Godfrey" userId="4d1c4f67dfec645c" providerId="LiveId" clId="{A7C33E27-2546-46F0-A1ED-B77B724F2654}"/>
-    <pc:docChg chg="undo custSel addSld delSld modSld">
-      <pc:chgData name="Daniel Godfrey" userId="4d1c4f67dfec645c" providerId="LiveId" clId="{A7C33E27-2546-46F0-A1ED-B77B724F2654}" dt="2026-09-23T19:14:56.874" v="2623" actId="20577"/>
+    <pc:docChg chg="undo custSel addSld delSld modSld sldOrd">
+      <pc:chgData name="Daniel Godfrey" userId="4d1c4f67dfec645c" providerId="LiveId" clId="{A7C33E27-2546-46F0-A1ED-B77B724F2654}" dt="2026-09-23T21:34:21.763" v="3656" actId="20577"/>
       <pc:docMkLst>
         <pc:docMk/>
       </pc:docMkLst>
-      <pc:sldChg chg="delSp modSp mod modClrScheme chgLayout">
-        <pc:chgData name="Daniel Godfrey" userId="4d1c4f67dfec645c" providerId="LiveId" clId="{A7C33E27-2546-46F0-A1ED-B77B724F2654}" dt="2026-09-23T18:40:13.357" v="1149" actId="20577"/>
+      <pc:sldChg chg="modSp mod">
+        <pc:chgData name="Daniel Godfrey" userId="4d1c4f67dfec645c" providerId="LiveId" clId="{A7C33E27-2546-46F0-A1ED-B77B724F2654}" dt="2026-09-23T21:24:01.716" v="3239" actId="20577"/>
+        <pc:sldMkLst>
+          <pc:docMk/>
+          <pc:sldMk cId="2326874819" sldId="256"/>
+        </pc:sldMkLst>
+        <pc:spChg chg="mod">
+          <ac:chgData name="Daniel Godfrey" userId="4d1c4f67dfec645c" providerId="LiveId" clId="{A7C33E27-2546-46F0-A1ED-B77B724F2654}" dt="2026-09-23T21:24:01.716" v="3239" actId="20577"/>
+          <ac:spMkLst>
+            <pc:docMk/>
+            <pc:sldMk cId="2326874819" sldId="256"/>
+            <ac:spMk id="2" creationId="{38374354-9C5B-7E28-9D25-47FD3DF84755}"/>
+          </ac:spMkLst>
+        </pc:spChg>
+      </pc:sldChg>
+      <pc:sldChg chg="ord">
+        <pc:chgData name="Daniel Godfrey" userId="4d1c4f67dfec645c" providerId="LiveId" clId="{A7C33E27-2546-46F0-A1ED-B77B724F2654}" dt="2026-09-23T21:16:57.356" v="2674"/>
+        <pc:sldMkLst>
+          <pc:docMk/>
+          <pc:sldMk cId="3897109198" sldId="257"/>
+        </pc:sldMkLst>
+      </pc:sldChg>
+      <pc:sldChg chg="delSp modSp mod ord modClrScheme chgLayout">
+        <pc:chgData name="Daniel Godfrey" userId="4d1c4f67dfec645c" providerId="LiveId" clId="{A7C33E27-2546-46F0-A1ED-B77B724F2654}" dt="2026-09-23T21:16:59.512" v="2676"/>
         <pc:sldMkLst>
           <pc:docMk/>
           <pc:sldMk cId="3078252523" sldId="258"/>
@@ -279,13 +309,13 @@
         </pc:spChg>
       </pc:sldChg>
       <pc:sldChg chg="addSp delSp modSp new mod modClrScheme chgLayout">
-        <pc:chgData name="Daniel Godfrey" userId="4d1c4f67dfec645c" providerId="LiveId" clId="{A7C33E27-2546-46F0-A1ED-B77B724F2654}" dt="2026-09-23T19:14:56.874" v="2623" actId="20577"/>
+        <pc:chgData name="Daniel Godfrey" userId="4d1c4f67dfec645c" providerId="LiveId" clId="{A7C33E27-2546-46F0-A1ED-B77B724F2654}" dt="2026-09-23T21:23:55.903" v="3236" actId="20577"/>
         <pc:sldMkLst>
           <pc:docMk/>
           <pc:sldMk cId="744662836" sldId="260"/>
         </pc:sldMkLst>
         <pc:spChg chg="mod ord">
-          <ac:chgData name="Daniel Godfrey" userId="4d1c4f67dfec645c" providerId="LiveId" clId="{A7C33E27-2546-46F0-A1ED-B77B724F2654}" dt="2026-09-23T19:14:56.874" v="2623" actId="20577"/>
+          <ac:chgData name="Daniel Godfrey" userId="4d1c4f67dfec645c" providerId="LiveId" clId="{A7C33E27-2546-46F0-A1ED-B77B724F2654}" dt="2026-09-23T21:23:55.903" v="3236" actId="20577"/>
           <ac:spMkLst>
             <pc:docMk/>
             <pc:sldMk cId="744662836" sldId="260"/>
@@ -353,6 +383,107 @@
             <pc:docMk/>
             <pc:sldMk cId="672901582" sldId="261"/>
             <ac:spMk id="5" creationId="{0B81AA8D-BE49-20D0-AF40-0E6F3F48F186}"/>
+          </ac:spMkLst>
+        </pc:spChg>
+      </pc:sldChg>
+      <pc:sldChg chg="addSp delSp modSp new mod ord setBg modClrScheme chgLayout">
+        <pc:chgData name="Daniel Godfrey" userId="4d1c4f67dfec645c" providerId="LiveId" clId="{A7C33E27-2546-46F0-A1ED-B77B724F2654}" dt="2026-09-23T21:27:27.826" v="3524" actId="26606"/>
+        <pc:sldMkLst>
+          <pc:docMk/>
+          <pc:sldMk cId="3498279973" sldId="261"/>
+        </pc:sldMkLst>
+        <pc:spChg chg="mod ord">
+          <ac:chgData name="Daniel Godfrey" userId="4d1c4f67dfec645c" providerId="LiveId" clId="{A7C33E27-2546-46F0-A1ED-B77B724F2654}" dt="2026-09-23T21:27:27.826" v="3524" actId="26606"/>
+          <ac:spMkLst>
+            <pc:docMk/>
+            <pc:sldMk cId="3498279973" sldId="261"/>
+            <ac:spMk id="2" creationId="{69D8F39B-982A-28C7-7891-8DD710BD7DB1}"/>
+          </ac:spMkLst>
+        </pc:spChg>
+        <pc:spChg chg="mod ord">
+          <ac:chgData name="Daniel Godfrey" userId="4d1c4f67dfec645c" providerId="LiveId" clId="{A7C33E27-2546-46F0-A1ED-B77B724F2654}" dt="2026-09-23T21:27:27.826" v="3524" actId="26606"/>
+          <ac:spMkLst>
+            <pc:docMk/>
+            <pc:sldMk cId="3498279973" sldId="261"/>
+            <ac:spMk id="3" creationId="{C5E6171D-470A-3D53-8135-5D54C4231A17}"/>
+          </ac:spMkLst>
+        </pc:spChg>
+        <pc:spChg chg="add mod ord">
+          <ac:chgData name="Daniel Godfrey" userId="4d1c4f67dfec645c" providerId="LiveId" clId="{A7C33E27-2546-46F0-A1ED-B77B724F2654}" dt="2026-09-23T21:27:27.826" v="3524" actId="26606"/>
+          <ac:spMkLst>
+            <pc:docMk/>
+            <pc:sldMk cId="3498279973" sldId="261"/>
+            <ac:spMk id="4" creationId="{04CE4F73-337D-2FDD-9E5F-69D5B309795F}"/>
+          </ac:spMkLst>
+        </pc:spChg>
+        <pc:spChg chg="add del">
+          <ac:chgData name="Daniel Godfrey" userId="4d1c4f67dfec645c" providerId="LiveId" clId="{A7C33E27-2546-46F0-A1ED-B77B724F2654}" dt="2026-09-23T21:27:27.826" v="3524" actId="26606"/>
+          <ac:spMkLst>
+            <pc:docMk/>
+            <pc:sldMk cId="3498279973" sldId="261"/>
+            <ac:spMk id="9" creationId="{428D436F-9ACD-4C92-AFC8-C934C527A6A4}"/>
+          </ac:spMkLst>
+        </pc:spChg>
+        <pc:spChg chg="add del">
+          <ac:chgData name="Daniel Godfrey" userId="4d1c4f67dfec645c" providerId="LiveId" clId="{A7C33E27-2546-46F0-A1ED-B77B724F2654}" dt="2026-09-23T21:27:27.826" v="3524" actId="26606"/>
+          <ac:spMkLst>
+            <pc:docMk/>
+            <pc:sldMk cId="3498279973" sldId="261"/>
+            <ac:spMk id="11" creationId="{090538E0-A884-4E60-A6AB-77D830E2FCED}"/>
+          </ac:spMkLst>
+        </pc:spChg>
+        <pc:spChg chg="add del">
+          <ac:chgData name="Daniel Godfrey" userId="4d1c4f67dfec645c" providerId="LiveId" clId="{A7C33E27-2546-46F0-A1ED-B77B724F2654}" dt="2026-09-23T21:27:27.826" v="3524" actId="26606"/>
+          <ac:spMkLst>
+            <pc:docMk/>
+            <pc:sldMk cId="3498279973" sldId="261"/>
+            <ac:spMk id="13" creationId="{DB0D7DD0-1C67-4D4C-9E06-678233DB8468}"/>
+          </ac:spMkLst>
+        </pc:spChg>
+      </pc:sldChg>
+      <pc:sldChg chg="modSp new mod ord">
+        <pc:chgData name="Daniel Godfrey" userId="4d1c4f67dfec645c" providerId="LiveId" clId="{A7C33E27-2546-46F0-A1ED-B77B724F2654}" dt="2026-09-23T21:32:06.475" v="3531" actId="20577"/>
+        <pc:sldMkLst>
+          <pc:docMk/>
+          <pc:sldMk cId="2771778418" sldId="262"/>
+        </pc:sldMkLst>
+        <pc:spChg chg="mod">
+          <ac:chgData name="Daniel Godfrey" userId="4d1c4f67dfec645c" providerId="LiveId" clId="{A7C33E27-2546-46F0-A1ED-B77B724F2654}" dt="2026-09-23T21:32:06.475" v="3531" actId="20577"/>
+          <ac:spMkLst>
+            <pc:docMk/>
+            <pc:sldMk cId="2771778418" sldId="262"/>
+            <ac:spMk id="2" creationId="{FA2A28DD-5751-79EF-EEE1-535D08A5A4C9}"/>
+          </ac:spMkLst>
+        </pc:spChg>
+        <pc:spChg chg="mod">
+          <ac:chgData name="Daniel Godfrey" userId="4d1c4f67dfec645c" providerId="LiveId" clId="{A7C33E27-2546-46F0-A1ED-B77B724F2654}" dt="2026-09-23T21:24:31.187" v="3257" actId="20577"/>
+          <ac:spMkLst>
+            <pc:docMk/>
+            <pc:sldMk cId="2771778418" sldId="262"/>
+            <ac:spMk id="3" creationId="{5D23E728-2DFA-532E-9A7E-6E5C0B20F6B5}"/>
+          </ac:spMkLst>
+        </pc:spChg>
+      </pc:sldChg>
+      <pc:sldChg chg="modSp new mod">
+        <pc:chgData name="Daniel Godfrey" userId="4d1c4f67dfec645c" providerId="LiveId" clId="{A7C33E27-2546-46F0-A1ED-B77B724F2654}" dt="2026-09-23T21:34:21.763" v="3656" actId="20577"/>
+        <pc:sldMkLst>
+          <pc:docMk/>
+          <pc:sldMk cId="2901282975" sldId="263"/>
+        </pc:sldMkLst>
+        <pc:spChg chg="mod">
+          <ac:chgData name="Daniel Godfrey" userId="4d1c4f67dfec645c" providerId="LiveId" clId="{A7C33E27-2546-46F0-A1ED-B77B724F2654}" dt="2026-09-23T21:32:18.904" v="3535" actId="20577"/>
+          <ac:spMkLst>
+            <pc:docMk/>
+            <pc:sldMk cId="2901282975" sldId="263"/>
+            <ac:spMk id="2" creationId="{08F270D3-3B2F-2E1A-1FED-25E20DD555EE}"/>
+          </ac:spMkLst>
+        </pc:spChg>
+        <pc:spChg chg="mod">
+          <ac:chgData name="Daniel Godfrey" userId="4d1c4f67dfec645c" providerId="LiveId" clId="{A7C33E27-2546-46F0-A1ED-B77B724F2654}" dt="2026-09-23T21:34:21.763" v="3656" actId="20577"/>
+          <ac:spMkLst>
+            <pc:docMk/>
+            <pc:sldMk cId="2901282975" sldId="263"/>
+            <ac:spMk id="3" creationId="{0C023EFE-17BA-9188-A550-EA4E09EBDBE2}"/>
           </ac:spMkLst>
         </pc:spChg>
       </pc:sldChg>
@@ -3607,7 +3738,7 @@
             </a:br>
             <a:r>
               <a:rPr lang="en-US" sz="5400" dirty="0"/>
-              <a:t>System Overview</a:t>
+              <a:t>App Overview</a:t>
             </a:r>
           </a:p>
         </p:txBody>
@@ -3690,7 +3821,7 @@
           <a:p>
             <a:r>
               <a:rPr lang="en-US" dirty="0"/>
-              <a:t>System Description</a:t>
+              <a:t>App Description</a:t>
             </a:r>
           </a:p>
         </p:txBody>
@@ -3795,6 +3926,570 @@
 </file>
 
 <file path=ppt/slides/slide3.xml><?xml version="1.0" encoding="utf-8"?>
+<p:sld xmlns:a="http://schemas.openxmlformats.org/drawingml/2006/main" xmlns:r="http://schemas.openxmlformats.org/officeDocument/2006/relationships" xmlns:p="http://schemas.openxmlformats.org/presentationml/2006/main">
+  <p:cSld>
+    <p:spTree>
+      <p:nvGrpSpPr>
+        <p:cNvPr id="1" name=""/>
+        <p:cNvGrpSpPr/>
+        <p:nvPr/>
+      </p:nvGrpSpPr>
+      <p:grpSpPr>
+        <a:xfrm>
+          <a:off x="0" y="0"/>
+          <a:ext cx="0" cy="0"/>
+          <a:chOff x="0" y="0"/>
+          <a:chExt cx="0" cy="0"/>
+        </a:xfrm>
+      </p:grpSpPr>
+      <p:sp>
+        <p:nvSpPr>
+          <p:cNvPr id="2" name="Title 1">
+            <a:extLst>
+              <a:ext uri="{FF2B5EF4-FFF2-40B4-BE49-F238E27FC236}">
+                <a16:creationId xmlns:a16="http://schemas.microsoft.com/office/drawing/2014/main" id="{FA2A28DD-5751-79EF-EEE1-535D08A5A4C9}"/>
+              </a:ext>
+            </a:extLst>
+          </p:cNvPr>
+          <p:cNvSpPr>
+            <a:spLocks noGrp="1"/>
+          </p:cNvSpPr>
+          <p:nvPr>
+            <p:ph type="title"/>
+          </p:nvPr>
+        </p:nvSpPr>
+        <p:spPr/>
+        <p:txBody>
+          <a:bodyPr/>
+          <a:lstStyle/>
+          <a:p>
+            <a:r>
+              <a:rPr lang="en-US" dirty="0"/>
+              <a:t>App Epic (User Story) #1</a:t>
+            </a:r>
+          </a:p>
+        </p:txBody>
+      </p:sp>
+      <p:sp>
+        <p:nvSpPr>
+          <p:cNvPr id="3" name="Content Placeholder 2">
+            <a:extLst>
+              <a:ext uri="{FF2B5EF4-FFF2-40B4-BE49-F238E27FC236}">
+                <a16:creationId xmlns:a16="http://schemas.microsoft.com/office/drawing/2014/main" id="{5D23E728-2DFA-532E-9A7E-6E5C0B20F6B5}"/>
+              </a:ext>
+            </a:extLst>
+          </p:cNvPr>
+          <p:cNvSpPr>
+            <a:spLocks noGrp="1"/>
+          </p:cNvSpPr>
+          <p:nvPr>
+            <p:ph idx="1"/>
+          </p:nvPr>
+        </p:nvSpPr>
+        <p:spPr/>
+        <p:txBody>
+          <a:bodyPr/>
+          <a:lstStyle/>
+          <a:p>
+            <a:r>
+              <a:rPr lang="en-US" dirty="0"/>
+              <a:t>User wants to learn new material by rote</a:t>
+            </a:r>
+          </a:p>
+          <a:p>
+            <a:pPr marL="914400" lvl="1" indent="-457200">
+              <a:buFont typeface="+mj-lt"/>
+              <a:buAutoNum type="arabicPeriod"/>
+            </a:pPr>
+            <a:r>
+              <a:rPr lang="en-US" dirty="0"/>
+              <a:t>User makes sure new material is in </a:t>
+            </a:r>
+            <a:r>
+              <a:rPr lang="en-US" i="1" dirty="0"/>
+              <a:t>Materials</a:t>
+            </a:r>
+            <a:r>
+              <a:rPr lang="en-US" dirty="0"/>
+              <a:t> database</a:t>
+            </a:r>
+          </a:p>
+          <a:p>
+            <a:pPr marL="914400" lvl="1" indent="-457200">
+              <a:buFont typeface="+mj-lt"/>
+              <a:buAutoNum type="arabicPeriod"/>
+            </a:pPr>
+            <a:r>
+              <a:rPr lang="en-US" dirty="0"/>
+              <a:t>To facilitate memorization, user enables as many aids as possible in </a:t>
+            </a:r>
+            <a:r>
+              <a:rPr lang="en-US" i="1" dirty="0"/>
+              <a:t>Settings Editor</a:t>
+            </a:r>
+          </a:p>
+          <a:p>
+            <a:pPr marL="914400" lvl="1" indent="-457200">
+              <a:buFont typeface="+mj-lt"/>
+              <a:buAutoNum type="arabicPeriod"/>
+            </a:pPr>
+            <a:r>
+              <a:rPr lang="en-US" dirty="0"/>
+              <a:t>User creates regimen testing themselves on new material with </a:t>
+            </a:r>
+            <a:r>
+              <a:rPr lang="en-US" i="1" dirty="0"/>
+              <a:t>Game Modes/Rules</a:t>
+            </a:r>
+          </a:p>
+          <a:p>
+            <a:pPr marL="914400" lvl="1" indent="-457200">
+              <a:buFont typeface="+mj-lt"/>
+              <a:buAutoNum type="arabicPeriod"/>
+            </a:pPr>
+            <a:r>
+              <a:rPr lang="en-US" dirty="0"/>
+              <a:t>User plays </a:t>
+            </a:r>
+            <a:r>
+              <a:rPr lang="en-US" i="1" dirty="0"/>
+              <a:t>Game</a:t>
+            </a:r>
+          </a:p>
+          <a:p>
+            <a:pPr marL="914400" lvl="1" indent="-457200">
+              <a:buFont typeface="+mj-lt"/>
+              <a:buAutoNum type="arabicPeriod"/>
+            </a:pPr>
+            <a:r>
+              <a:rPr lang="en-US" dirty="0"/>
+              <a:t>User refers to </a:t>
+            </a:r>
+            <a:r>
+              <a:rPr lang="en-US" i="1" dirty="0"/>
+              <a:t>Outputs</a:t>
+            </a:r>
+            <a:r>
+              <a:rPr lang="en-US" dirty="0"/>
+              <a:t> and </a:t>
+            </a:r>
+            <a:r>
+              <a:rPr lang="en-US" i="1" dirty="0"/>
+              <a:t>Logs</a:t>
+            </a:r>
+            <a:r>
+              <a:rPr lang="en-US" dirty="0"/>
+              <a:t> to evaluate memorization performance and problem areas</a:t>
+            </a:r>
+          </a:p>
+          <a:p>
+            <a:pPr marL="914400" lvl="1" indent="-457200">
+              <a:buFont typeface="+mj-lt"/>
+              <a:buAutoNum type="arabicPeriod"/>
+            </a:pPr>
+            <a:r>
+              <a:rPr lang="en-US" dirty="0"/>
+              <a:t>User does Steps 2-5 until new material is memorized satisfactorily</a:t>
+            </a:r>
+          </a:p>
+          <a:p>
+            <a:endParaRPr lang="en-US" dirty="0"/>
+          </a:p>
+        </p:txBody>
+      </p:sp>
+    </p:spTree>
+    <p:extLst>
+      <p:ext uri="{BB962C8B-B14F-4D97-AF65-F5344CB8AC3E}">
+        <p14:creationId xmlns:p14="http://schemas.microsoft.com/office/powerpoint/2010/main" val="2771778418"/>
+      </p:ext>
+    </p:extLst>
+  </p:cSld>
+  <p:clrMapOvr>
+    <a:masterClrMapping/>
+  </p:clrMapOvr>
+</p:sld>
+</file>
+
+<file path=ppt/slides/slide4.xml><?xml version="1.0" encoding="utf-8"?>
+<p:sld xmlns:a="http://schemas.openxmlformats.org/drawingml/2006/main" xmlns:r="http://schemas.openxmlformats.org/officeDocument/2006/relationships" xmlns:p="http://schemas.openxmlformats.org/presentationml/2006/main">
+  <p:cSld>
+    <p:spTree>
+      <p:nvGrpSpPr>
+        <p:cNvPr id="1" name=""/>
+        <p:cNvGrpSpPr/>
+        <p:nvPr/>
+      </p:nvGrpSpPr>
+      <p:grpSpPr>
+        <a:xfrm>
+          <a:off x="0" y="0"/>
+          <a:ext cx="0" cy="0"/>
+          <a:chOff x="0" y="0"/>
+          <a:chExt cx="0" cy="0"/>
+        </a:xfrm>
+      </p:grpSpPr>
+      <p:sp>
+        <p:nvSpPr>
+          <p:cNvPr id="2" name="Title 1">
+            <a:extLst>
+              <a:ext uri="{FF2B5EF4-FFF2-40B4-BE49-F238E27FC236}">
+                <a16:creationId xmlns:a16="http://schemas.microsoft.com/office/drawing/2014/main" id="{08F270D3-3B2F-2E1A-1FED-25E20DD555EE}"/>
+              </a:ext>
+            </a:extLst>
+          </p:cNvPr>
+          <p:cNvSpPr>
+            <a:spLocks noGrp="1"/>
+          </p:cNvSpPr>
+          <p:nvPr>
+            <p:ph type="title"/>
+          </p:nvPr>
+        </p:nvSpPr>
+        <p:spPr/>
+        <p:txBody>
+          <a:bodyPr/>
+          <a:lstStyle/>
+          <a:p>
+            <a:r>
+              <a:rPr lang="en-US" dirty="0"/>
+              <a:t>App Epic (User Story) #2</a:t>
+            </a:r>
+          </a:p>
+        </p:txBody>
+      </p:sp>
+      <p:sp>
+        <p:nvSpPr>
+          <p:cNvPr id="3" name="Content Placeholder 2">
+            <a:extLst>
+              <a:ext uri="{FF2B5EF4-FFF2-40B4-BE49-F238E27FC236}">
+                <a16:creationId xmlns:a16="http://schemas.microsoft.com/office/drawing/2014/main" id="{0C023EFE-17BA-9188-A550-EA4E09EBDBE2}"/>
+              </a:ext>
+            </a:extLst>
+          </p:cNvPr>
+          <p:cNvSpPr>
+            <a:spLocks noGrp="1"/>
+          </p:cNvSpPr>
+          <p:nvPr>
+            <p:ph idx="1"/>
+          </p:nvPr>
+        </p:nvSpPr>
+        <p:spPr/>
+        <p:txBody>
+          <a:bodyPr/>
+          <a:lstStyle/>
+          <a:p>
+            <a:r>
+              <a:rPr lang="en-US" dirty="0"/>
+              <a:t>User wants to emulate reciting material unaided</a:t>
+            </a:r>
+          </a:p>
+          <a:p>
+            <a:pPr marL="914400" lvl="1" indent="-457200">
+              <a:buFont typeface="+mj-lt"/>
+              <a:buAutoNum type="arabicPeriod"/>
+            </a:pPr>
+            <a:r>
+              <a:rPr lang="en-US" dirty="0"/>
+              <a:t>User makes sure material is in </a:t>
+            </a:r>
+            <a:r>
+              <a:rPr lang="en-US" i="1" dirty="0"/>
+              <a:t>Materials</a:t>
+            </a:r>
+            <a:r>
+              <a:rPr lang="en-US" dirty="0"/>
+              <a:t> database</a:t>
+            </a:r>
+          </a:p>
+          <a:p>
+            <a:pPr marL="914400" lvl="1" indent="-457200">
+              <a:buFont typeface="+mj-lt"/>
+              <a:buAutoNum type="arabicPeriod"/>
+            </a:pPr>
+            <a:r>
+              <a:rPr lang="en-US" dirty="0"/>
+              <a:t>To emulate recitation, user </a:t>
+            </a:r>
+            <a:r>
+              <a:rPr lang="en-US" b="1" dirty="0"/>
+              <a:t>dis</a:t>
+            </a:r>
+            <a:r>
+              <a:rPr lang="en-US" dirty="0"/>
+              <a:t>ables as many aids as possible in </a:t>
+            </a:r>
+            <a:r>
+              <a:rPr lang="en-US" i="1" dirty="0"/>
+              <a:t>Settings Editor</a:t>
+            </a:r>
+          </a:p>
+          <a:p>
+            <a:pPr marL="914400" lvl="1" indent="-457200">
+              <a:buFont typeface="+mj-lt"/>
+              <a:buAutoNum type="arabicPeriod"/>
+            </a:pPr>
+            <a:r>
+              <a:rPr lang="en-US" dirty="0"/>
+              <a:t>User uses default regimen (sequential) to test themselves on material with </a:t>
+            </a:r>
+            <a:r>
+              <a:rPr lang="en-US" i="1" dirty="0"/>
+              <a:t>Game Modes/Rules</a:t>
+            </a:r>
+          </a:p>
+          <a:p>
+            <a:pPr marL="914400" lvl="1" indent="-457200">
+              <a:buFont typeface="+mj-lt"/>
+              <a:buAutoNum type="arabicPeriod"/>
+            </a:pPr>
+            <a:r>
+              <a:rPr lang="en-US" dirty="0"/>
+              <a:t>User plays </a:t>
+            </a:r>
+            <a:r>
+              <a:rPr lang="en-US" i="1" dirty="0"/>
+              <a:t>Game</a:t>
+            </a:r>
+          </a:p>
+          <a:p>
+            <a:pPr marL="914400" lvl="1" indent="-457200">
+              <a:buFont typeface="+mj-lt"/>
+              <a:buAutoNum type="arabicPeriod"/>
+            </a:pPr>
+            <a:r>
+              <a:rPr lang="en-US" dirty="0"/>
+              <a:t>User refers to </a:t>
+            </a:r>
+            <a:r>
+              <a:rPr lang="en-US" i="1" dirty="0"/>
+              <a:t>Outputs</a:t>
+            </a:r>
+            <a:r>
+              <a:rPr lang="en-US" dirty="0"/>
+              <a:t> and </a:t>
+            </a:r>
+            <a:r>
+              <a:rPr lang="en-US" i="1" dirty="0"/>
+              <a:t>Logs</a:t>
+            </a:r>
+            <a:r>
+              <a:rPr lang="en-US" dirty="0"/>
+              <a:t> to evaluate recitation performance and problem areas</a:t>
+            </a:r>
+          </a:p>
+          <a:p>
+            <a:pPr marL="914400" lvl="1" indent="-457200">
+              <a:buFont typeface="+mj-lt"/>
+              <a:buAutoNum type="arabicPeriod"/>
+            </a:pPr>
+            <a:r>
+              <a:rPr lang="en-US" dirty="0"/>
+              <a:t>User does Steps 2-5 until new material has been recited satisfactorily</a:t>
+            </a:r>
+          </a:p>
+          <a:p>
+            <a:endParaRPr lang="en-US" dirty="0"/>
+          </a:p>
+          <a:p>
+            <a:endParaRPr lang="en-US" dirty="0"/>
+          </a:p>
+        </p:txBody>
+      </p:sp>
+    </p:spTree>
+    <p:extLst>
+      <p:ext uri="{BB962C8B-B14F-4D97-AF65-F5344CB8AC3E}">
+        <p14:creationId xmlns:p14="http://schemas.microsoft.com/office/powerpoint/2010/main" val="2901282975"/>
+      </p:ext>
+    </p:extLst>
+  </p:cSld>
+  <p:clrMapOvr>
+    <a:masterClrMapping/>
+  </p:clrMapOvr>
+</p:sld>
+</file>
+
+<file path=ppt/slides/slide5.xml><?xml version="1.0" encoding="utf-8"?>
+<p:sld xmlns:a="http://schemas.openxmlformats.org/drawingml/2006/main" xmlns:r="http://schemas.openxmlformats.org/officeDocument/2006/relationships" xmlns:p="http://schemas.openxmlformats.org/presentationml/2006/main">
+  <p:cSld>
+    <p:spTree>
+      <p:nvGrpSpPr>
+        <p:cNvPr id="1" name=""/>
+        <p:cNvGrpSpPr/>
+        <p:nvPr/>
+      </p:nvGrpSpPr>
+      <p:grpSpPr>
+        <a:xfrm>
+          <a:off x="0" y="0"/>
+          <a:ext cx="0" cy="0"/>
+          <a:chOff x="0" y="0"/>
+          <a:chExt cx="0" cy="0"/>
+        </a:xfrm>
+      </p:grpSpPr>
+      <p:sp>
+        <p:nvSpPr>
+          <p:cNvPr id="2" name="Title 1">
+            <a:extLst>
+              <a:ext uri="{FF2B5EF4-FFF2-40B4-BE49-F238E27FC236}">
+                <a16:creationId xmlns:a16="http://schemas.microsoft.com/office/drawing/2014/main" id="{69D8F39B-982A-28C7-7891-8DD710BD7DB1}"/>
+              </a:ext>
+            </a:extLst>
+          </p:cNvPr>
+          <p:cNvSpPr>
+            <a:spLocks noGrp="1"/>
+          </p:cNvSpPr>
+          <p:nvPr>
+            <p:ph type="title"/>
+          </p:nvPr>
+        </p:nvSpPr>
+        <p:spPr/>
+        <p:txBody>
+          <a:bodyPr/>
+          <a:lstStyle/>
+          <a:p>
+            <a:r>
+              <a:rPr lang="en-US"/>
+              <a:t>App Storyboard</a:t>
+            </a:r>
+            <a:endParaRPr lang="en-US" dirty="0"/>
+          </a:p>
+        </p:txBody>
+      </p:sp>
+      <p:sp>
+        <p:nvSpPr>
+          <p:cNvPr id="3" name="Content Placeholder 2">
+            <a:extLst>
+              <a:ext uri="{FF2B5EF4-FFF2-40B4-BE49-F238E27FC236}">
+                <a16:creationId xmlns:a16="http://schemas.microsoft.com/office/drawing/2014/main" id="{C5E6171D-470A-3D53-8135-5D54C4231A17}"/>
+              </a:ext>
+            </a:extLst>
+          </p:cNvPr>
+          <p:cNvSpPr>
+            <a:spLocks noGrp="1"/>
+          </p:cNvSpPr>
+          <p:nvPr>
+            <p:ph sz="half" idx="1"/>
+          </p:nvPr>
+        </p:nvSpPr>
+        <p:spPr/>
+        <p:txBody>
+          <a:bodyPr/>
+          <a:lstStyle/>
+          <a:p>
+            <a:r>
+              <a:rPr lang="en-US"/>
+              <a:t>Screens for typical use</a:t>
+            </a:r>
+          </a:p>
+          <a:p>
+            <a:pPr marL="914400" lvl="1" indent="-457200">
+              <a:buFont typeface="+mj-lt"/>
+              <a:buAutoNum type="arabicPeriod"/>
+            </a:pPr>
+            <a:r>
+              <a:rPr lang="en-US"/>
+              <a:t>Choose Material</a:t>
+            </a:r>
+          </a:p>
+          <a:p>
+            <a:pPr marL="914400" lvl="1" indent="-457200">
+              <a:buFont typeface="+mj-lt"/>
+              <a:buAutoNum type="arabicPeriod"/>
+            </a:pPr>
+            <a:r>
+              <a:rPr lang="en-US"/>
+              <a:t>Settings (Agree to Defaults)</a:t>
+            </a:r>
+          </a:p>
+          <a:p>
+            <a:pPr marL="914400" lvl="1" indent="-457200">
+              <a:buFont typeface="+mj-lt"/>
+              <a:buAutoNum type="arabicPeriod"/>
+            </a:pPr>
+            <a:r>
+              <a:rPr lang="en-US"/>
+              <a:t>Choose minigame/mode</a:t>
+            </a:r>
+          </a:p>
+          <a:p>
+            <a:pPr marL="914400" lvl="1" indent="-457200">
+              <a:buFont typeface="+mj-lt"/>
+              <a:buAutoNum type="arabicPeriod"/>
+            </a:pPr>
+            <a:r>
+              <a:rPr lang="en-US"/>
+              <a:t>Play game / start screen / Screen i</a:t>
+            </a:r>
+          </a:p>
+          <a:p>
+            <a:pPr marL="914400" lvl="1" indent="-457200">
+              <a:buFont typeface="+mj-lt"/>
+              <a:buAutoNum type="arabicPeriod"/>
+            </a:pPr>
+            <a:r>
+              <a:rPr lang="en-US"/>
+              <a:t>Pause Screen?</a:t>
+            </a:r>
+          </a:p>
+          <a:p>
+            <a:pPr marL="914400" lvl="1" indent="-457200">
+              <a:buFont typeface="+mj-lt"/>
+              <a:buAutoNum type="arabicPeriod"/>
+            </a:pPr>
+            <a:r>
+              <a:rPr lang="en-US"/>
+              <a:t>Next Screen / Screen i+1</a:t>
+            </a:r>
+          </a:p>
+          <a:p>
+            <a:pPr marL="914400" lvl="1" indent="-457200">
+              <a:buFont typeface="+mj-lt"/>
+              <a:buAutoNum type="arabicPeriod"/>
+            </a:pPr>
+            <a:r>
+              <a:rPr lang="en-US"/>
+              <a:t>End Screen (Game Over screen?)</a:t>
+            </a:r>
+            <a:endParaRPr lang="en-US" dirty="0"/>
+          </a:p>
+        </p:txBody>
+      </p:sp>
+      <p:sp>
+        <p:nvSpPr>
+          <p:cNvPr id="4" name="Content Placeholder 3">
+            <a:extLst>
+              <a:ext uri="{FF2B5EF4-FFF2-40B4-BE49-F238E27FC236}">
+                <a16:creationId xmlns:a16="http://schemas.microsoft.com/office/drawing/2014/main" id="{04CE4F73-337D-2FDD-9E5F-69D5B309795F}"/>
+              </a:ext>
+            </a:extLst>
+          </p:cNvPr>
+          <p:cNvSpPr>
+            <a:spLocks noGrp="1"/>
+          </p:cNvSpPr>
+          <p:nvPr>
+            <p:ph sz="half" idx="2"/>
+          </p:nvPr>
+        </p:nvSpPr>
+        <p:spPr/>
+        <p:txBody>
+          <a:bodyPr/>
+          <a:lstStyle/>
+          <a:p>
+            <a:endParaRPr lang="en-US"/>
+          </a:p>
+        </p:txBody>
+      </p:sp>
+    </p:spTree>
+    <p:extLst>
+      <p:ext uri="{BB962C8B-B14F-4D97-AF65-F5344CB8AC3E}">
+        <p14:creationId xmlns:p14="http://schemas.microsoft.com/office/powerpoint/2010/main" val="3498279973"/>
+      </p:ext>
+    </p:extLst>
+  </p:cSld>
+  <p:clrMapOvr>
+    <a:masterClrMapping/>
+  </p:clrMapOvr>
+</p:sld>
+</file>
+
+<file path=ppt/slides/slide6.xml><?xml version="1.0" encoding="utf-8"?>
 <p:sld xmlns:a="http://schemas.openxmlformats.org/drawingml/2006/main" xmlns:r="http://schemas.openxmlformats.org/officeDocument/2006/relationships" xmlns:p="http://schemas.openxmlformats.org/presentationml/2006/main">
   <p:cSld>
     <p:spTree>
@@ -4872,7 +5567,7 @@
 </p:sld>
 </file>
 
-<file path=ppt/slides/slide4.xml><?xml version="1.0" encoding="utf-8"?>
+<file path=ppt/slides/slide7.xml><?xml version="1.0" encoding="utf-8"?>
 <p:sld xmlns:a="http://schemas.openxmlformats.org/drawingml/2006/main" xmlns:r="http://schemas.openxmlformats.org/officeDocument/2006/relationships" xmlns:p="http://schemas.openxmlformats.org/presentationml/2006/main">
   <p:cSld>
     <p:spTree>
@@ -5144,7 +5839,7 @@
 </p:sld>
 </file>
 
-<file path=ppt/slides/slide5.xml><?xml version="1.0" encoding="utf-8"?>
+<file path=ppt/slides/slide8.xml><?xml version="1.0" encoding="utf-8"?>
 <p:sld xmlns:a="http://schemas.openxmlformats.org/drawingml/2006/main" xmlns:r="http://schemas.openxmlformats.org/officeDocument/2006/relationships" xmlns:p="http://schemas.openxmlformats.org/presentationml/2006/main">
   <p:cSld>
     <p:spTree>

</xml_diff>

<commit_message>
:memo: Add new user story to docs
</commit_message>
<xml_diff>
--- a/doc/bmc-system-charts.pptx
+++ b/doc/bmc-system-charts.pptx
@@ -9,10 +9,11 @@
     <p:sldId id="260" r:id="rId3"/>
     <p:sldId id="262" r:id="rId4"/>
     <p:sldId id="263" r:id="rId5"/>
-    <p:sldId id="261" r:id="rId6"/>
-    <p:sldId id="257" r:id="rId7"/>
-    <p:sldId id="258" r:id="rId8"/>
-    <p:sldId id="259" r:id="rId9"/>
+    <p:sldId id="264" r:id="rId6"/>
+    <p:sldId id="261" r:id="rId7"/>
+    <p:sldId id="257" r:id="rId8"/>
+    <p:sldId id="258" r:id="rId9"/>
+    <p:sldId id="259" r:id="rId10"/>
   </p:sldIdLst>
   <p:sldSz cx="12192000" cy="6858000"/>
   <p:notesSz cx="6858000" cy="9144000"/>
@@ -122,7 +123,7 @@
 <file path=ppt/revisionInfo.xml><?xml version="1.0" encoding="utf-8"?>
 <p1510:revInfo xmlns:a="http://schemas.openxmlformats.org/drawingml/2006/main" xmlns:r="http://schemas.openxmlformats.org/officeDocument/2006/relationships" xmlns:p1510="http://schemas.microsoft.com/office/powerpoint/2015/10/main">
   <p1510:revLst>
-    <p1510:client id="{6D8F685D-64B7-49F8-B054-0F740B6185A0}" v="13" dt="2026-09-23T21:33:29.788"/>
+    <p1510:client id="{6D8F685D-64B7-49F8-B054-0F740B6185A0}" v="14" dt="2026-09-27T02:50:15.550"/>
   </p1510:revLst>
 </p1510:revInfo>
 </file>
@@ -132,7 +133,7 @@
   <pc:docChgLst>
     <pc:chgData name="Daniel Godfrey" userId="4d1c4f67dfec645c" providerId="LiveId" clId="{A7C33E27-2546-46F0-A1ED-B77B724F2654}"/>
     <pc:docChg chg="undo custSel addSld delSld modSld sldOrd">
-      <pc:chgData name="Daniel Godfrey" userId="4d1c4f67dfec645c" providerId="LiveId" clId="{A7C33E27-2546-46F0-A1ED-B77B724F2654}" dt="2026-09-23T21:34:21.763" v="3656" actId="20577"/>
+      <pc:chgData name="Daniel Godfrey" userId="4d1c4f67dfec645c" providerId="LiveId" clId="{A7C33E27-2546-46F0-A1ED-B77B724F2654}" dt="2026-09-27T02:52:10.713" v="3774" actId="20577"/>
       <pc:docMkLst>
         <pc:docMk/>
       </pc:docMkLst>
@@ -188,22 +189,6 @@
             <ac:spMk id="6" creationId="{4C77B8B2-6193-101F-7579-2186EA381158}"/>
           </ac:spMkLst>
         </pc:spChg>
-        <pc:spChg chg="del mod ord">
-          <ac:chgData name="Daniel Godfrey" userId="4d1c4f67dfec645c" providerId="LiveId" clId="{A7C33E27-2546-46F0-A1ED-B77B724F2654}" dt="2026-09-23T18:39:22.594" v="1089" actId="478"/>
-          <ac:spMkLst>
-            <pc:docMk/>
-            <pc:sldMk cId="3078252523" sldId="258"/>
-            <ac:spMk id="7" creationId="{54801607-A88F-28BE-8EB4-F919844DBFC6}"/>
-          </ac:spMkLst>
-        </pc:spChg>
-        <pc:spChg chg="del mod ord">
-          <ac:chgData name="Daniel Godfrey" userId="4d1c4f67dfec645c" providerId="LiveId" clId="{A7C33E27-2546-46F0-A1ED-B77B724F2654}" dt="2026-09-23T18:39:25.910" v="1090" actId="478"/>
-          <ac:spMkLst>
-            <pc:docMk/>
-            <pc:sldMk cId="3078252523" sldId="258"/>
-            <ac:spMk id="8" creationId="{2D7CFD80-3D46-DBE6-E5A7-D4579A4AEB96}"/>
-          </ac:spMkLst>
-        </pc:spChg>
       </pc:sldChg>
       <pc:sldChg chg="addSp delSp modSp new mod modClrScheme chgLayout">
         <pc:chgData name="Daniel Godfrey" userId="4d1c4f67dfec645c" providerId="LiveId" clId="{A7C33E27-2546-46F0-A1ED-B77B724F2654}" dt="2026-09-23T19:02:30.229" v="2463" actId="20577"/>
@@ -211,62 +196,6 @@
           <pc:docMk/>
           <pc:sldMk cId="1303700019" sldId="259"/>
         </pc:sldMkLst>
-        <pc:spChg chg="del mod ord">
-          <ac:chgData name="Daniel Godfrey" userId="4d1c4f67dfec645c" providerId="LiveId" clId="{A7C33E27-2546-46F0-A1ED-B77B724F2654}" dt="2026-09-23T18:23:31.321" v="1" actId="700"/>
-          <ac:spMkLst>
-            <pc:docMk/>
-            <pc:sldMk cId="1303700019" sldId="259"/>
-            <ac:spMk id="2" creationId="{36E7697F-6FA8-E585-58A1-8AC5D204287B}"/>
-          </ac:spMkLst>
-        </pc:spChg>
-        <pc:spChg chg="del">
-          <ac:chgData name="Daniel Godfrey" userId="4d1c4f67dfec645c" providerId="LiveId" clId="{A7C33E27-2546-46F0-A1ED-B77B724F2654}" dt="2026-09-23T18:23:31.321" v="1" actId="700"/>
-          <ac:spMkLst>
-            <pc:docMk/>
-            <pc:sldMk cId="1303700019" sldId="259"/>
-            <ac:spMk id="3" creationId="{EFDB8F55-7860-D247-2845-0122FCCD9602}"/>
-          </ac:spMkLst>
-        </pc:spChg>
-        <pc:spChg chg="del mod ord">
-          <ac:chgData name="Daniel Godfrey" userId="4d1c4f67dfec645c" providerId="LiveId" clId="{A7C33E27-2546-46F0-A1ED-B77B724F2654}" dt="2026-09-23T18:23:31.321" v="1" actId="700"/>
-          <ac:spMkLst>
-            <pc:docMk/>
-            <pc:sldMk cId="1303700019" sldId="259"/>
-            <ac:spMk id="4" creationId="{4364B6A7-1893-C920-CD1E-7F85936C555E}"/>
-          </ac:spMkLst>
-        </pc:spChg>
-        <pc:spChg chg="del">
-          <ac:chgData name="Daniel Godfrey" userId="4d1c4f67dfec645c" providerId="LiveId" clId="{A7C33E27-2546-46F0-A1ED-B77B724F2654}" dt="2026-09-23T18:23:31.321" v="1" actId="700"/>
-          <ac:spMkLst>
-            <pc:docMk/>
-            <pc:sldMk cId="1303700019" sldId="259"/>
-            <ac:spMk id="5" creationId="{7FF0D6DB-5C4E-790D-F40A-652761189717}"/>
-          </ac:spMkLst>
-        </pc:spChg>
-        <pc:spChg chg="del">
-          <ac:chgData name="Daniel Godfrey" userId="4d1c4f67dfec645c" providerId="LiveId" clId="{A7C33E27-2546-46F0-A1ED-B77B724F2654}" dt="2026-09-23T18:23:31.321" v="1" actId="700"/>
-          <ac:spMkLst>
-            <pc:docMk/>
-            <pc:sldMk cId="1303700019" sldId="259"/>
-            <ac:spMk id="6" creationId="{0480ACBB-61B6-BDAC-9D90-4AA796616FDE}"/>
-          </ac:spMkLst>
-        </pc:spChg>
-        <pc:spChg chg="add del mod ord">
-          <ac:chgData name="Daniel Godfrey" userId="4d1c4f67dfec645c" providerId="LiveId" clId="{A7C33E27-2546-46F0-A1ED-B77B724F2654}" dt="2026-09-23T18:23:39.324" v="2" actId="700"/>
-          <ac:spMkLst>
-            <pc:docMk/>
-            <pc:sldMk cId="1303700019" sldId="259"/>
-            <ac:spMk id="7" creationId="{13740DE9-BF17-EE01-9975-0B5B618D5B57}"/>
-          </ac:spMkLst>
-        </pc:spChg>
-        <pc:spChg chg="add del mod ord">
-          <ac:chgData name="Daniel Godfrey" userId="4d1c4f67dfec645c" providerId="LiveId" clId="{A7C33E27-2546-46F0-A1ED-B77B724F2654}" dt="2026-09-23T18:23:39.324" v="2" actId="700"/>
-          <ac:spMkLst>
-            <pc:docMk/>
-            <pc:sldMk cId="1303700019" sldId="259"/>
-            <ac:spMk id="8" creationId="{B0CF79AE-16A0-A2A7-BFC1-EFA30CBC37E8}"/>
-          </ac:spMkLst>
-        </pc:spChg>
         <pc:spChg chg="add mod ord">
           <ac:chgData name="Daniel Godfrey" userId="4d1c4f67dfec645c" providerId="LiveId" clId="{A7C33E27-2546-46F0-A1ED-B77B724F2654}" dt="2026-09-23T18:28:48.161" v="506" actId="700"/>
           <ac:spMkLst>
@@ -275,28 +204,12 @@
             <ac:spMk id="9" creationId="{DDA0A674-AE31-F785-ED5B-FBD2BBFE8004}"/>
           </ac:spMkLst>
         </pc:spChg>
-        <pc:spChg chg="add del mod ord">
-          <ac:chgData name="Daniel Godfrey" userId="4d1c4f67dfec645c" providerId="LiveId" clId="{A7C33E27-2546-46F0-A1ED-B77B724F2654}" dt="2026-09-23T18:28:53.353" v="507" actId="478"/>
-          <ac:spMkLst>
-            <pc:docMk/>
-            <pc:sldMk cId="1303700019" sldId="259"/>
-            <ac:spMk id="10" creationId="{45EE6F10-C32B-5A0E-7E03-065DA2899029}"/>
-          </ac:spMkLst>
-        </pc:spChg>
         <pc:spChg chg="add mod ord">
           <ac:chgData name="Daniel Godfrey" userId="4d1c4f67dfec645c" providerId="LiveId" clId="{A7C33E27-2546-46F0-A1ED-B77B724F2654}" dt="2026-09-23T19:02:30.229" v="2463" actId="20577"/>
           <ac:spMkLst>
             <pc:docMk/>
             <pc:sldMk cId="1303700019" sldId="259"/>
             <ac:spMk id="11" creationId="{F4345111-B260-2DC9-9622-1512092957F9}"/>
-          </ac:spMkLst>
-        </pc:spChg>
-        <pc:spChg chg="add del mod ord">
-          <ac:chgData name="Daniel Godfrey" userId="4d1c4f67dfec645c" providerId="LiveId" clId="{A7C33E27-2546-46F0-A1ED-B77B724F2654}" dt="2026-09-23T18:28:58.541" v="508" actId="478"/>
-          <ac:spMkLst>
-            <pc:docMk/>
-            <pc:sldMk cId="1303700019" sldId="259"/>
-            <ac:spMk id="12" creationId="{40F0AA1E-EF92-DBE5-209B-AC0C2D251579}"/>
           </ac:spMkLst>
         </pc:spChg>
         <pc:spChg chg="add mod ord">
@@ -322,67 +235,12 @@
             <ac:spMk id="2" creationId="{7A4C44ED-FD1A-3112-D14D-CA28C45B9631}"/>
           </ac:spMkLst>
         </pc:spChg>
-        <pc:spChg chg="del mod ord">
-          <ac:chgData name="Daniel Godfrey" userId="4d1c4f67dfec645c" providerId="LiveId" clId="{A7C33E27-2546-46F0-A1ED-B77B724F2654}" dt="2026-09-23T18:41:07.407" v="1170" actId="700"/>
-          <ac:spMkLst>
-            <pc:docMk/>
-            <pc:sldMk cId="744662836" sldId="260"/>
-            <ac:spMk id="3" creationId="{4B9D92B5-AD2A-03CC-7EC2-6C01014A61A7}"/>
-          </ac:spMkLst>
-        </pc:spChg>
         <pc:spChg chg="add mod ord">
           <ac:chgData name="Daniel Godfrey" userId="4d1c4f67dfec645c" providerId="LiveId" clId="{A7C33E27-2546-46F0-A1ED-B77B724F2654}" dt="2026-09-23T19:08:36.659" v="2606" actId="27636"/>
           <ac:spMkLst>
             <pc:docMk/>
             <pc:sldMk cId="744662836" sldId="260"/>
             <ac:spMk id="4" creationId="{77E609C4-FA99-23B2-886E-8BAAE47332AA}"/>
-          </ac:spMkLst>
-        </pc:spChg>
-        <pc:spChg chg="add del mod ord">
-          <ac:chgData name="Daniel Godfrey" userId="4d1c4f67dfec645c" providerId="LiveId" clId="{A7C33E27-2546-46F0-A1ED-B77B724F2654}" dt="2026-09-23T18:41:55.226" v="1244" actId="700"/>
-          <ac:spMkLst>
-            <pc:docMk/>
-            <pc:sldMk cId="744662836" sldId="260"/>
-            <ac:spMk id="5" creationId="{6000610A-334C-B56C-A9DA-C034750CC34F}"/>
-          </ac:spMkLst>
-        </pc:spChg>
-      </pc:sldChg>
-      <pc:sldChg chg="addSp delSp modSp new del mod modClrScheme chgLayout">
-        <pc:chgData name="Daniel Godfrey" userId="4d1c4f67dfec645c" providerId="LiveId" clId="{A7C33E27-2546-46F0-A1ED-B77B724F2654}" dt="2026-09-23T19:14:48.580" v="2608" actId="2696"/>
-        <pc:sldMkLst>
-          <pc:docMk/>
-          <pc:sldMk cId="672901582" sldId="261"/>
-        </pc:sldMkLst>
-        <pc:spChg chg="mod ord">
-          <ac:chgData name="Daniel Godfrey" userId="4d1c4f67dfec645c" providerId="LiveId" clId="{A7C33E27-2546-46F0-A1ED-B77B724F2654}" dt="2026-09-23T18:43:52.431" v="1404" actId="700"/>
-          <ac:spMkLst>
-            <pc:docMk/>
-            <pc:sldMk cId="672901582" sldId="261"/>
-            <ac:spMk id="2" creationId="{77366D62-0FAB-56EA-5A29-EF20334C829C}"/>
-          </ac:spMkLst>
-        </pc:spChg>
-        <pc:spChg chg="del mod ord">
-          <ac:chgData name="Daniel Godfrey" userId="4d1c4f67dfec645c" providerId="LiveId" clId="{A7C33E27-2546-46F0-A1ED-B77B724F2654}" dt="2026-09-23T18:42:32.480" v="1287" actId="700"/>
-          <ac:spMkLst>
-            <pc:docMk/>
-            <pc:sldMk cId="672901582" sldId="261"/>
-            <ac:spMk id="3" creationId="{9D312469-71D0-92BC-B456-F699A6833044}"/>
-          </ac:spMkLst>
-        </pc:spChg>
-        <pc:spChg chg="add mod ord">
-          <ac:chgData name="Daniel Godfrey" userId="4d1c4f67dfec645c" providerId="LiveId" clId="{A7C33E27-2546-46F0-A1ED-B77B724F2654}" dt="2026-09-23T19:14:43.889" v="2607" actId="20577"/>
-          <ac:spMkLst>
-            <pc:docMk/>
-            <pc:sldMk cId="672901582" sldId="261"/>
-            <ac:spMk id="4" creationId="{403AEFF4-5310-6F67-C4C4-9C92CBB99E70}"/>
-          </ac:spMkLst>
-        </pc:spChg>
-        <pc:spChg chg="add del mod ord">
-          <ac:chgData name="Daniel Godfrey" userId="4d1c4f67dfec645c" providerId="LiveId" clId="{A7C33E27-2546-46F0-A1ED-B77B724F2654}" dt="2026-09-23T18:43:52.431" v="1404" actId="700"/>
-          <ac:spMkLst>
-            <pc:docMk/>
-            <pc:sldMk cId="672901582" sldId="261"/>
-            <ac:spMk id="5" creationId="{0B81AA8D-BE49-20D0-AF40-0E6F3F48F186}"/>
           </ac:spMkLst>
         </pc:spChg>
       </pc:sldChg>
@@ -416,39 +274,15 @@
             <ac:spMk id="4" creationId="{04CE4F73-337D-2FDD-9E5F-69D5B309795F}"/>
           </ac:spMkLst>
         </pc:spChg>
-        <pc:spChg chg="add del">
-          <ac:chgData name="Daniel Godfrey" userId="4d1c4f67dfec645c" providerId="LiveId" clId="{A7C33E27-2546-46F0-A1ED-B77B724F2654}" dt="2026-09-23T21:27:27.826" v="3524" actId="26606"/>
-          <ac:spMkLst>
-            <pc:docMk/>
-            <pc:sldMk cId="3498279973" sldId="261"/>
-            <ac:spMk id="9" creationId="{428D436F-9ACD-4C92-AFC8-C934C527A6A4}"/>
-          </ac:spMkLst>
-        </pc:spChg>
-        <pc:spChg chg="add del">
-          <ac:chgData name="Daniel Godfrey" userId="4d1c4f67dfec645c" providerId="LiveId" clId="{A7C33E27-2546-46F0-A1ED-B77B724F2654}" dt="2026-09-23T21:27:27.826" v="3524" actId="26606"/>
-          <ac:spMkLst>
-            <pc:docMk/>
-            <pc:sldMk cId="3498279973" sldId="261"/>
-            <ac:spMk id="11" creationId="{090538E0-A884-4E60-A6AB-77D830E2FCED}"/>
-          </ac:spMkLst>
-        </pc:spChg>
-        <pc:spChg chg="add del">
-          <ac:chgData name="Daniel Godfrey" userId="4d1c4f67dfec645c" providerId="LiveId" clId="{A7C33E27-2546-46F0-A1ED-B77B724F2654}" dt="2026-09-23T21:27:27.826" v="3524" actId="26606"/>
-          <ac:spMkLst>
-            <pc:docMk/>
-            <pc:sldMk cId="3498279973" sldId="261"/>
-            <ac:spMk id="13" creationId="{DB0D7DD0-1C67-4D4C-9E06-678233DB8468}"/>
-          </ac:spMkLst>
-        </pc:spChg>
       </pc:sldChg>
       <pc:sldChg chg="modSp new mod ord">
-        <pc:chgData name="Daniel Godfrey" userId="4d1c4f67dfec645c" providerId="LiveId" clId="{A7C33E27-2546-46F0-A1ED-B77B724F2654}" dt="2026-09-23T21:32:06.475" v="3531" actId="20577"/>
+        <pc:chgData name="Daniel Godfrey" userId="4d1c4f67dfec645c" providerId="LiveId" clId="{A7C33E27-2546-46F0-A1ED-B77B724F2654}" dt="2026-09-27T02:52:10.713" v="3774" actId="20577"/>
         <pc:sldMkLst>
           <pc:docMk/>
           <pc:sldMk cId="2771778418" sldId="262"/>
         </pc:sldMkLst>
         <pc:spChg chg="mod">
-          <ac:chgData name="Daniel Godfrey" userId="4d1c4f67dfec645c" providerId="LiveId" clId="{A7C33E27-2546-46F0-A1ED-B77B724F2654}" dt="2026-09-23T21:32:06.475" v="3531" actId="20577"/>
+          <ac:chgData name="Daniel Godfrey" userId="4d1c4f67dfec645c" providerId="LiveId" clId="{A7C33E27-2546-46F0-A1ED-B77B724F2654}" dt="2026-09-27T02:52:10.713" v="3774" actId="20577"/>
           <ac:spMkLst>
             <pc:docMk/>
             <pc:sldMk cId="2771778418" sldId="262"/>
@@ -465,13 +299,13 @@
         </pc:spChg>
       </pc:sldChg>
       <pc:sldChg chg="modSp new mod">
-        <pc:chgData name="Daniel Godfrey" userId="4d1c4f67dfec645c" providerId="LiveId" clId="{A7C33E27-2546-46F0-A1ED-B77B724F2654}" dt="2026-09-23T21:34:21.763" v="3656" actId="20577"/>
+        <pc:chgData name="Daniel Godfrey" userId="4d1c4f67dfec645c" providerId="LiveId" clId="{A7C33E27-2546-46F0-A1ED-B77B724F2654}" dt="2026-09-27T02:52:03.417" v="3760" actId="20577"/>
         <pc:sldMkLst>
           <pc:docMk/>
           <pc:sldMk cId="2901282975" sldId="263"/>
         </pc:sldMkLst>
         <pc:spChg chg="mod">
-          <ac:chgData name="Daniel Godfrey" userId="4d1c4f67dfec645c" providerId="LiveId" clId="{A7C33E27-2546-46F0-A1ED-B77B724F2654}" dt="2026-09-23T21:32:18.904" v="3535" actId="20577"/>
+          <ac:chgData name="Daniel Godfrey" userId="4d1c4f67dfec645c" providerId="LiveId" clId="{A7C33E27-2546-46F0-A1ED-B77B724F2654}" dt="2026-09-27T02:52:03.417" v="3760" actId="20577"/>
           <ac:spMkLst>
             <pc:docMk/>
             <pc:sldMk cId="2901282975" sldId="263"/>
@@ -479,11 +313,34 @@
           </ac:spMkLst>
         </pc:spChg>
         <pc:spChg chg="mod">
-          <ac:chgData name="Daniel Godfrey" userId="4d1c4f67dfec645c" providerId="LiveId" clId="{A7C33E27-2546-46F0-A1ED-B77B724F2654}" dt="2026-09-23T21:34:21.763" v="3656" actId="20577"/>
+          <ac:chgData name="Daniel Godfrey" userId="4d1c4f67dfec645c" providerId="LiveId" clId="{A7C33E27-2546-46F0-A1ED-B77B724F2654}" dt="2026-09-27T02:50:56.043" v="3699" actId="20577"/>
           <ac:spMkLst>
             <pc:docMk/>
             <pc:sldMk cId="2901282975" sldId="263"/>
             <ac:spMk id="3" creationId="{0C023EFE-17BA-9188-A550-EA4E09EBDBE2}"/>
+          </ac:spMkLst>
+        </pc:spChg>
+      </pc:sldChg>
+      <pc:sldChg chg="modSp add mod">
+        <pc:chgData name="Daniel Godfrey" userId="4d1c4f67dfec645c" providerId="LiveId" clId="{A7C33E27-2546-46F0-A1ED-B77B724F2654}" dt="2026-09-27T02:51:56.332" v="3751" actId="20577"/>
+        <pc:sldMkLst>
+          <pc:docMk/>
+          <pc:sldMk cId="9819867" sldId="264"/>
+        </pc:sldMkLst>
+        <pc:spChg chg="mod">
+          <ac:chgData name="Daniel Godfrey" userId="4d1c4f67dfec645c" providerId="LiveId" clId="{A7C33E27-2546-46F0-A1ED-B77B724F2654}" dt="2026-09-27T02:51:56.332" v="3751" actId="20577"/>
+          <ac:spMkLst>
+            <pc:docMk/>
+            <pc:sldMk cId="9819867" sldId="264"/>
+            <ac:spMk id="2" creationId="{CADCDEAF-7940-A4F7-6B91-B423A3012327}"/>
+          </ac:spMkLst>
+        </pc:spChg>
+        <pc:spChg chg="mod">
+          <ac:chgData name="Daniel Godfrey" userId="4d1c4f67dfec645c" providerId="LiveId" clId="{A7C33E27-2546-46F0-A1ED-B77B724F2654}" dt="2026-09-27T02:51:45.946" v="3739" actId="20577"/>
+          <ac:spMkLst>
+            <pc:docMk/>
+            <pc:sldMk cId="9819867" sldId="264"/>
+            <ac:spMk id="3" creationId="{D2B02830-B8E4-C3D0-35E0-0AEDCCC6404F}"/>
           </ac:spMkLst>
         </pc:spChg>
       </pc:sldChg>
@@ -639,7 +496,7 @@
           <a:p>
             <a:fld id="{32EB0E7F-F65E-4199-9595-3B5AFA646589}" type="datetimeFigureOut">
               <a:rPr lang="en-US" smtClean="0"/>
-              <a:t>9/23/2026</a:t>
+              <a:t>9/26/2026</a:t>
             </a:fld>
             <a:endParaRPr lang="en-US"/>
           </a:p>
@@ -837,7 +694,7 @@
           <a:p>
             <a:fld id="{32EB0E7F-F65E-4199-9595-3B5AFA646589}" type="datetimeFigureOut">
               <a:rPr lang="en-US" smtClean="0"/>
-              <a:t>9/23/2026</a:t>
+              <a:t>9/26/2026</a:t>
             </a:fld>
             <a:endParaRPr lang="en-US"/>
           </a:p>
@@ -1045,7 +902,7 @@
           <a:p>
             <a:fld id="{32EB0E7F-F65E-4199-9595-3B5AFA646589}" type="datetimeFigureOut">
               <a:rPr lang="en-US" smtClean="0"/>
-              <a:t>9/23/2026</a:t>
+              <a:t>9/26/2026</a:t>
             </a:fld>
             <a:endParaRPr lang="en-US"/>
           </a:p>
@@ -1243,7 +1100,7 @@
           <a:p>
             <a:fld id="{32EB0E7F-F65E-4199-9595-3B5AFA646589}" type="datetimeFigureOut">
               <a:rPr lang="en-US" smtClean="0"/>
-              <a:t>9/23/2026</a:t>
+              <a:t>9/26/2026</a:t>
             </a:fld>
             <a:endParaRPr lang="en-US"/>
           </a:p>
@@ -1518,7 +1375,7 @@
           <a:p>
             <a:fld id="{32EB0E7F-F65E-4199-9595-3B5AFA646589}" type="datetimeFigureOut">
               <a:rPr lang="en-US" smtClean="0"/>
-              <a:t>9/23/2026</a:t>
+              <a:t>9/26/2026</a:t>
             </a:fld>
             <a:endParaRPr lang="en-US"/>
           </a:p>
@@ -1783,7 +1640,7 @@
           <a:p>
             <a:fld id="{32EB0E7F-F65E-4199-9595-3B5AFA646589}" type="datetimeFigureOut">
               <a:rPr lang="en-US" smtClean="0"/>
-              <a:t>9/23/2026</a:t>
+              <a:t>9/26/2026</a:t>
             </a:fld>
             <a:endParaRPr lang="en-US"/>
           </a:p>
@@ -2195,7 +2052,7 @@
           <a:p>
             <a:fld id="{32EB0E7F-F65E-4199-9595-3B5AFA646589}" type="datetimeFigureOut">
               <a:rPr lang="en-US" smtClean="0"/>
-              <a:t>9/23/2026</a:t>
+              <a:t>9/26/2026</a:t>
             </a:fld>
             <a:endParaRPr lang="en-US"/>
           </a:p>
@@ -2336,7 +2193,7 @@
           <a:p>
             <a:fld id="{32EB0E7F-F65E-4199-9595-3B5AFA646589}" type="datetimeFigureOut">
               <a:rPr lang="en-US" smtClean="0"/>
-              <a:t>9/23/2026</a:t>
+              <a:t>9/26/2026</a:t>
             </a:fld>
             <a:endParaRPr lang="en-US"/>
           </a:p>
@@ -2449,7 +2306,7 @@
           <a:p>
             <a:fld id="{32EB0E7F-F65E-4199-9595-3B5AFA646589}" type="datetimeFigureOut">
               <a:rPr lang="en-US" smtClean="0"/>
-              <a:t>9/23/2026</a:t>
+              <a:t>9/26/2026</a:t>
             </a:fld>
             <a:endParaRPr lang="en-US"/>
           </a:p>
@@ -2760,7 +2617,7 @@
           <a:p>
             <a:fld id="{32EB0E7F-F65E-4199-9595-3B5AFA646589}" type="datetimeFigureOut">
               <a:rPr lang="en-US" smtClean="0"/>
-              <a:t>9/23/2026</a:t>
+              <a:t>9/26/2026</a:t>
             </a:fld>
             <a:endParaRPr lang="en-US"/>
           </a:p>
@@ -3048,7 +2905,7 @@
           <a:p>
             <a:fld id="{32EB0E7F-F65E-4199-9595-3B5AFA646589}" type="datetimeFigureOut">
               <a:rPr lang="en-US" smtClean="0"/>
-              <a:t>9/23/2026</a:t>
+              <a:t>9/26/2026</a:t>
             </a:fld>
             <a:endParaRPr lang="en-US"/>
           </a:p>
@@ -3289,7 +3146,7 @@
           <a:p>
             <a:fld id="{32EB0E7F-F65E-4199-9595-3B5AFA646589}" type="datetimeFigureOut">
               <a:rPr lang="en-US" smtClean="0"/>
-              <a:t>9/23/2026</a:t>
+              <a:t>9/26/2026</a:t>
             </a:fld>
             <a:endParaRPr lang="en-US"/>
           </a:p>
@@ -3965,7 +3822,7 @@
           <a:p>
             <a:r>
               <a:rPr lang="en-US" dirty="0"/>
-              <a:t>App Epic (User Story) #1</a:t>
+              <a:t>App Epic (User Story) #1: Memorizing</a:t>
             </a:r>
           </a:p>
         </p:txBody>
@@ -4150,7 +4007,7 @@
           <a:p>
             <a:r>
               <a:rPr lang="en-US" dirty="0"/>
-              <a:t>App Epic (User Story) #2</a:t>
+              <a:t>App Epic (User Story) #2: Quoting</a:t>
             </a:r>
           </a:p>
         </p:txBody>
@@ -4311,6 +4168,208 @@
   <p:cSld>
     <p:spTree>
       <p:nvGrpSpPr>
+        <p:cNvPr id="1" name="">
+          <a:extLst>
+            <a:ext uri="{FF2B5EF4-FFF2-40B4-BE49-F238E27FC236}">
+              <a16:creationId xmlns:a16="http://schemas.microsoft.com/office/drawing/2014/main" id="{685A5B25-BF9F-7186-A4F2-103F57BD8DCD}"/>
+            </a:ext>
+          </a:extLst>
+        </p:cNvPr>
+        <p:cNvGrpSpPr/>
+        <p:nvPr/>
+      </p:nvGrpSpPr>
+      <p:grpSpPr>
+        <a:xfrm>
+          <a:off x="0" y="0"/>
+          <a:ext cx="0" cy="0"/>
+          <a:chOff x="0" y="0"/>
+          <a:chExt cx="0" cy="0"/>
+        </a:xfrm>
+      </p:grpSpPr>
+      <p:sp>
+        <p:nvSpPr>
+          <p:cNvPr id="2" name="Title 1">
+            <a:extLst>
+              <a:ext uri="{FF2B5EF4-FFF2-40B4-BE49-F238E27FC236}">
+                <a16:creationId xmlns:a16="http://schemas.microsoft.com/office/drawing/2014/main" id="{CADCDEAF-7940-A4F7-6B91-B423A3012327}"/>
+              </a:ext>
+            </a:extLst>
+          </p:cNvPr>
+          <p:cNvSpPr>
+            <a:spLocks noGrp="1"/>
+          </p:cNvSpPr>
+          <p:nvPr>
+            <p:ph type="title"/>
+          </p:nvPr>
+        </p:nvSpPr>
+        <p:spPr/>
+        <p:txBody>
+          <a:bodyPr/>
+          <a:lstStyle/>
+          <a:p>
+            <a:r>
+              <a:rPr lang="en-US" dirty="0"/>
+              <a:t>App Epic (User Story) #3: Memory Bee</a:t>
+            </a:r>
+          </a:p>
+        </p:txBody>
+      </p:sp>
+      <p:sp>
+        <p:nvSpPr>
+          <p:cNvPr id="3" name="Content Placeholder 2">
+            <a:extLst>
+              <a:ext uri="{FF2B5EF4-FFF2-40B4-BE49-F238E27FC236}">
+                <a16:creationId xmlns:a16="http://schemas.microsoft.com/office/drawing/2014/main" id="{D2B02830-B8E4-C3D0-35E0-0AEDCCC6404F}"/>
+              </a:ext>
+            </a:extLst>
+          </p:cNvPr>
+          <p:cNvSpPr>
+            <a:spLocks noGrp="1"/>
+          </p:cNvSpPr>
+          <p:nvPr>
+            <p:ph idx="1"/>
+          </p:nvPr>
+        </p:nvSpPr>
+        <p:spPr/>
+        <p:txBody>
+          <a:bodyPr/>
+          <a:lstStyle/>
+          <a:p>
+            <a:r>
+              <a:rPr lang="en-US" dirty="0"/>
+              <a:t>User wants to emulate quiz/bee on material</a:t>
+            </a:r>
+          </a:p>
+          <a:p>
+            <a:pPr marL="914400" lvl="1" indent="-457200">
+              <a:buFont typeface="+mj-lt"/>
+              <a:buAutoNum type="arabicPeriod"/>
+            </a:pPr>
+            <a:r>
+              <a:rPr lang="en-US" dirty="0"/>
+              <a:t>User makes sure material is in </a:t>
+            </a:r>
+            <a:r>
+              <a:rPr lang="en-US" i="1" dirty="0"/>
+              <a:t>Materials</a:t>
+            </a:r>
+            <a:r>
+              <a:rPr lang="en-US" dirty="0"/>
+              <a:t> database</a:t>
+            </a:r>
+          </a:p>
+          <a:p>
+            <a:pPr marL="914400" lvl="1" indent="-457200">
+              <a:buFont typeface="+mj-lt"/>
+              <a:buAutoNum type="arabicPeriod"/>
+            </a:pPr>
+            <a:r>
+              <a:rPr lang="en-US" dirty="0"/>
+              <a:t>To emulate bee, user </a:t>
+            </a:r>
+            <a:r>
+              <a:rPr lang="en-US" b="1" dirty="0"/>
+              <a:t>dis</a:t>
+            </a:r>
+            <a:r>
+              <a:rPr lang="en-US" dirty="0"/>
+              <a:t>ables as many aids as possible in </a:t>
+            </a:r>
+            <a:r>
+              <a:rPr lang="en-US" i="1" dirty="0"/>
+              <a:t>Settings Editor</a:t>
+            </a:r>
+          </a:p>
+          <a:p>
+            <a:pPr marL="914400" lvl="1" indent="-457200">
+              <a:buFont typeface="+mj-lt"/>
+              <a:buAutoNum type="arabicPeriod"/>
+            </a:pPr>
+            <a:r>
+              <a:rPr lang="en-US" dirty="0"/>
+              <a:t>User uses regimen (randomized) to test themselves on material with </a:t>
+            </a:r>
+            <a:r>
+              <a:rPr lang="en-US" i="1" dirty="0"/>
+              <a:t>Game Modes/Rules</a:t>
+            </a:r>
+          </a:p>
+          <a:p>
+            <a:pPr marL="914400" lvl="1" indent="-457200">
+              <a:buFont typeface="+mj-lt"/>
+              <a:buAutoNum type="arabicPeriod"/>
+            </a:pPr>
+            <a:r>
+              <a:rPr lang="en-US" dirty="0"/>
+              <a:t>User plays </a:t>
+            </a:r>
+            <a:r>
+              <a:rPr lang="en-US" i="1" dirty="0"/>
+              <a:t>Game</a:t>
+            </a:r>
+          </a:p>
+          <a:p>
+            <a:pPr marL="914400" lvl="1" indent="-457200">
+              <a:buFont typeface="+mj-lt"/>
+              <a:buAutoNum type="arabicPeriod"/>
+            </a:pPr>
+            <a:r>
+              <a:rPr lang="en-US" dirty="0"/>
+              <a:t>User refers to </a:t>
+            </a:r>
+            <a:r>
+              <a:rPr lang="en-US" i="1" dirty="0"/>
+              <a:t>Outputs</a:t>
+            </a:r>
+            <a:r>
+              <a:rPr lang="en-US" dirty="0"/>
+              <a:t> and </a:t>
+            </a:r>
+            <a:r>
+              <a:rPr lang="en-US" i="1" dirty="0"/>
+              <a:t>Logs</a:t>
+            </a:r>
+            <a:r>
+              <a:rPr lang="en-US" dirty="0"/>
+              <a:t> to evaluate recitation performance and problem areas</a:t>
+            </a:r>
+          </a:p>
+          <a:p>
+            <a:pPr marL="914400" lvl="1" indent="-457200">
+              <a:buFont typeface="+mj-lt"/>
+              <a:buAutoNum type="arabicPeriod"/>
+            </a:pPr>
+            <a:r>
+              <a:rPr lang="en-US" dirty="0"/>
+              <a:t>User does Steps 2-5 until new material has been recited satisfactorily</a:t>
+            </a:r>
+          </a:p>
+          <a:p>
+            <a:endParaRPr lang="en-US" dirty="0"/>
+          </a:p>
+          <a:p>
+            <a:endParaRPr lang="en-US" dirty="0"/>
+          </a:p>
+        </p:txBody>
+      </p:sp>
+    </p:spTree>
+    <p:extLst>
+      <p:ext uri="{BB962C8B-B14F-4D97-AF65-F5344CB8AC3E}">
+        <p14:creationId xmlns:p14="http://schemas.microsoft.com/office/powerpoint/2010/main" val="9819867"/>
+      </p:ext>
+    </p:extLst>
+  </p:cSld>
+  <p:clrMapOvr>
+    <a:masterClrMapping/>
+  </p:clrMapOvr>
+</p:sld>
+</file>
+
+<file path=ppt/slides/slide6.xml><?xml version="1.0" encoding="utf-8"?>
+<p:sld xmlns:a="http://schemas.openxmlformats.org/drawingml/2006/main" xmlns:r="http://schemas.openxmlformats.org/officeDocument/2006/relationships" xmlns:p="http://schemas.openxmlformats.org/presentationml/2006/main">
+  <p:cSld>
+    <p:spTree>
+      <p:nvGrpSpPr>
         <p:cNvPr id="1" name=""/>
         <p:cNvGrpSpPr/>
         <p:nvPr/>
@@ -4489,7 +4548,7 @@
 </p:sld>
 </file>
 
-<file path=ppt/slides/slide6.xml><?xml version="1.0" encoding="utf-8"?>
+<file path=ppt/slides/slide7.xml><?xml version="1.0" encoding="utf-8"?>
 <p:sld xmlns:a="http://schemas.openxmlformats.org/drawingml/2006/main" xmlns:r="http://schemas.openxmlformats.org/officeDocument/2006/relationships" xmlns:p="http://schemas.openxmlformats.org/presentationml/2006/main">
   <p:cSld>
     <p:spTree>
@@ -5567,7 +5626,7 @@
 </p:sld>
 </file>
 
-<file path=ppt/slides/slide7.xml><?xml version="1.0" encoding="utf-8"?>
+<file path=ppt/slides/slide8.xml><?xml version="1.0" encoding="utf-8"?>
 <p:sld xmlns:a="http://schemas.openxmlformats.org/drawingml/2006/main" xmlns:r="http://schemas.openxmlformats.org/officeDocument/2006/relationships" xmlns:p="http://schemas.openxmlformats.org/presentationml/2006/main">
   <p:cSld>
     <p:spTree>
@@ -5839,7 +5898,7 @@
 </p:sld>
 </file>
 
-<file path=ppt/slides/slide8.xml><?xml version="1.0" encoding="utf-8"?>
+<file path=ppt/slides/slide9.xml><?xml version="1.0" encoding="utf-8"?>
 <p:sld xmlns:a="http://schemas.openxmlformats.org/drawingml/2006/main" xmlns:r="http://schemas.openxmlformats.org/officeDocument/2006/relationships" xmlns:p="http://schemas.openxmlformats.org/presentationml/2006/main">
   <p:cSld>
     <p:spTree>

</xml_diff>

<commit_message>
:truck: Rename files/classes for readability
I kept confusing several terms. This commit makes an effort to untangle those terms. I added a Glossary slide to the charts to help keep myself straight.
</commit_message>
<xml_diff>
--- a/doc/bmc-system-charts.pptx
+++ b/doc/bmc-system-charts.pptx
@@ -14,6 +14,7 @@
     <p:sldId id="257" r:id="rId8"/>
     <p:sldId id="258" r:id="rId9"/>
     <p:sldId id="259" r:id="rId10"/>
+    <p:sldId id="265" r:id="rId11"/>
   </p:sldIdLst>
   <p:sldSz cx="12192000" cy="6858000"/>
   <p:notesSz cx="6858000" cy="9144000"/>
@@ -123,7 +124,7 @@
 <file path=ppt/revisionInfo.xml><?xml version="1.0" encoding="utf-8"?>
 <p1510:revInfo xmlns:a="http://schemas.openxmlformats.org/drawingml/2006/main" xmlns:r="http://schemas.openxmlformats.org/officeDocument/2006/relationships" xmlns:p1510="http://schemas.microsoft.com/office/powerpoint/2015/10/main">
   <p1510:revLst>
-    <p1510:client id="{6D8F685D-64B7-49F8-B054-0F740B6185A0}" v="14" dt="2026-09-27T02:50:15.550"/>
+    <p1510:client id="{6D8F685D-64B7-49F8-B054-0F740B6185A0}" v="4" dt="2026-10-03T00:43:50.046"/>
   </p1510:revLst>
 </p1510:revInfo>
 </file>
@@ -133,18 +134,18 @@
   <pc:docChgLst>
     <pc:chgData name="Daniel Godfrey" userId="4d1c4f67dfec645c" providerId="LiveId" clId="{A7C33E27-2546-46F0-A1ED-B77B724F2654}"/>
     <pc:docChg chg="undo custSel addSld delSld modSld sldOrd">
-      <pc:chgData name="Daniel Godfrey" userId="4d1c4f67dfec645c" providerId="LiveId" clId="{A7C33E27-2546-46F0-A1ED-B77B724F2654}" dt="2026-09-27T02:52:10.713" v="3774" actId="20577"/>
+      <pc:chgData name="Daniel Godfrey" userId="4d1c4f67dfec645c" providerId="LiveId" clId="{A7C33E27-2546-46F0-A1ED-B77B724F2654}" dt="2026-10-03T01:15:30.942" v="5266"/>
       <pc:docMkLst>
         <pc:docMk/>
       </pc:docMkLst>
       <pc:sldChg chg="modSp mod">
-        <pc:chgData name="Daniel Godfrey" userId="4d1c4f67dfec645c" providerId="LiveId" clId="{A7C33E27-2546-46F0-A1ED-B77B724F2654}" dt="2026-09-23T21:24:01.716" v="3239" actId="20577"/>
+        <pc:chgData name="Daniel Godfrey" userId="4d1c4f67dfec645c" providerId="LiveId" clId="{A7C33E27-2546-46F0-A1ED-B77B724F2654}" dt="2026-10-03T00:29:18.387" v="3780" actId="115"/>
         <pc:sldMkLst>
           <pc:docMk/>
           <pc:sldMk cId="2326874819" sldId="256"/>
         </pc:sldMkLst>
         <pc:spChg chg="mod">
-          <ac:chgData name="Daniel Godfrey" userId="4d1c4f67dfec645c" providerId="LiveId" clId="{A7C33E27-2546-46F0-A1ED-B77B724F2654}" dt="2026-09-23T21:24:01.716" v="3239" actId="20577"/>
+          <ac:chgData name="Daniel Godfrey" userId="4d1c4f67dfec645c" providerId="LiveId" clId="{A7C33E27-2546-46F0-A1ED-B77B724F2654}" dt="2026-10-03T00:29:18.387" v="3780" actId="115"/>
           <ac:spMkLst>
             <pc:docMk/>
             <pc:sldMk cId="2326874819" sldId="256"/>
@@ -245,7 +246,7 @@
         </pc:spChg>
       </pc:sldChg>
       <pc:sldChg chg="addSp delSp modSp new mod ord setBg modClrScheme chgLayout">
-        <pc:chgData name="Daniel Godfrey" userId="4d1c4f67dfec645c" providerId="LiveId" clId="{A7C33E27-2546-46F0-A1ED-B77B724F2654}" dt="2026-09-23T21:27:27.826" v="3524" actId="26606"/>
+        <pc:chgData name="Daniel Godfrey" userId="4d1c4f67dfec645c" providerId="LiveId" clId="{A7C33E27-2546-46F0-A1ED-B77B724F2654}" dt="2026-10-03T01:11:34.740" v="5253" actId="20577"/>
         <pc:sldMkLst>
           <pc:docMk/>
           <pc:sldMk cId="3498279973" sldId="261"/>
@@ -259,7 +260,7 @@
           </ac:spMkLst>
         </pc:spChg>
         <pc:spChg chg="mod ord">
-          <ac:chgData name="Daniel Godfrey" userId="4d1c4f67dfec645c" providerId="LiveId" clId="{A7C33E27-2546-46F0-A1ED-B77B724F2654}" dt="2026-09-23T21:27:27.826" v="3524" actId="26606"/>
+          <ac:chgData name="Daniel Godfrey" userId="4d1c4f67dfec645c" providerId="LiveId" clId="{A7C33E27-2546-46F0-A1ED-B77B724F2654}" dt="2026-10-03T01:11:34.740" v="5253" actId="20577"/>
           <ac:spMkLst>
             <pc:docMk/>
             <pc:sldMk cId="3498279973" sldId="261"/>
@@ -344,6 +345,29 @@
           </ac:spMkLst>
         </pc:spChg>
       </pc:sldChg>
+      <pc:sldChg chg="modSp new mod ord">
+        <pc:chgData name="Daniel Godfrey" userId="4d1c4f67dfec645c" providerId="LiveId" clId="{A7C33E27-2546-46F0-A1ED-B77B724F2654}" dt="2026-10-03T01:15:30.942" v="5266"/>
+        <pc:sldMkLst>
+          <pc:docMk/>
+          <pc:sldMk cId="1493022053" sldId="265"/>
+        </pc:sldMkLst>
+        <pc:spChg chg="mod">
+          <ac:chgData name="Daniel Godfrey" userId="4d1c4f67dfec645c" providerId="LiveId" clId="{A7C33E27-2546-46F0-A1ED-B77B724F2654}" dt="2026-10-03T01:15:26.344" v="5264" actId="20577"/>
+          <ac:spMkLst>
+            <pc:docMk/>
+            <pc:sldMk cId="1493022053" sldId="265"/>
+            <ac:spMk id="2" creationId="{9BC690AF-0F05-830A-0ED8-ED12CF3E4ACD}"/>
+          </ac:spMkLst>
+        </pc:spChg>
+        <pc:spChg chg="mod">
+          <ac:chgData name="Daniel Godfrey" userId="4d1c4f67dfec645c" providerId="LiveId" clId="{A7C33E27-2546-46F0-A1ED-B77B724F2654}" dt="2026-10-03T01:00:42.788" v="5213" actId="6549"/>
+          <ac:spMkLst>
+            <pc:docMk/>
+            <pc:sldMk cId="1493022053" sldId="265"/>
+            <ac:spMk id="3" creationId="{297F69B7-E451-A515-BAA9-AD4D28EC0D9A}"/>
+          </ac:spMkLst>
+        </pc:spChg>
+      </pc:sldChg>
     </pc:docChg>
   </pc:docChgLst>
 </pc:chgInfo>
@@ -496,7 +520,7 @@
           <a:p>
             <a:fld id="{32EB0E7F-F65E-4199-9595-3B5AFA646589}" type="datetimeFigureOut">
               <a:rPr lang="en-US" smtClean="0"/>
-              <a:t>9/26/2026</a:t>
+              <a:t>10/2/2026</a:t>
             </a:fld>
             <a:endParaRPr lang="en-US"/>
           </a:p>
@@ -694,7 +718,7 @@
           <a:p>
             <a:fld id="{32EB0E7F-F65E-4199-9595-3B5AFA646589}" type="datetimeFigureOut">
               <a:rPr lang="en-US" smtClean="0"/>
-              <a:t>9/26/2026</a:t>
+              <a:t>10/2/2026</a:t>
             </a:fld>
             <a:endParaRPr lang="en-US"/>
           </a:p>
@@ -902,7 +926,7 @@
           <a:p>
             <a:fld id="{32EB0E7F-F65E-4199-9595-3B5AFA646589}" type="datetimeFigureOut">
               <a:rPr lang="en-US" smtClean="0"/>
-              <a:t>9/26/2026</a:t>
+              <a:t>10/2/2026</a:t>
             </a:fld>
             <a:endParaRPr lang="en-US"/>
           </a:p>
@@ -1100,7 +1124,7 @@
           <a:p>
             <a:fld id="{32EB0E7F-F65E-4199-9595-3B5AFA646589}" type="datetimeFigureOut">
               <a:rPr lang="en-US" smtClean="0"/>
-              <a:t>9/26/2026</a:t>
+              <a:t>10/2/2026</a:t>
             </a:fld>
             <a:endParaRPr lang="en-US"/>
           </a:p>
@@ -1375,7 +1399,7 @@
           <a:p>
             <a:fld id="{32EB0E7F-F65E-4199-9595-3B5AFA646589}" type="datetimeFigureOut">
               <a:rPr lang="en-US" smtClean="0"/>
-              <a:t>9/26/2026</a:t>
+              <a:t>10/2/2026</a:t>
             </a:fld>
             <a:endParaRPr lang="en-US"/>
           </a:p>
@@ -1640,7 +1664,7 @@
           <a:p>
             <a:fld id="{32EB0E7F-F65E-4199-9595-3B5AFA646589}" type="datetimeFigureOut">
               <a:rPr lang="en-US" smtClean="0"/>
-              <a:t>9/26/2026</a:t>
+              <a:t>10/2/2026</a:t>
             </a:fld>
             <a:endParaRPr lang="en-US"/>
           </a:p>
@@ -2052,7 +2076,7 @@
           <a:p>
             <a:fld id="{32EB0E7F-F65E-4199-9595-3B5AFA646589}" type="datetimeFigureOut">
               <a:rPr lang="en-US" smtClean="0"/>
-              <a:t>9/26/2026</a:t>
+              <a:t>10/2/2026</a:t>
             </a:fld>
             <a:endParaRPr lang="en-US"/>
           </a:p>
@@ -2193,7 +2217,7 @@
           <a:p>
             <a:fld id="{32EB0E7F-F65E-4199-9595-3B5AFA646589}" type="datetimeFigureOut">
               <a:rPr lang="en-US" smtClean="0"/>
-              <a:t>9/26/2026</a:t>
+              <a:t>10/2/2026</a:t>
             </a:fld>
             <a:endParaRPr lang="en-US"/>
           </a:p>
@@ -2306,7 +2330,7 @@
           <a:p>
             <a:fld id="{32EB0E7F-F65E-4199-9595-3B5AFA646589}" type="datetimeFigureOut">
               <a:rPr lang="en-US" smtClean="0"/>
-              <a:t>9/26/2026</a:t>
+              <a:t>10/2/2026</a:t>
             </a:fld>
             <a:endParaRPr lang="en-US"/>
           </a:p>
@@ -2617,7 +2641,7 @@
           <a:p>
             <a:fld id="{32EB0E7F-F65E-4199-9595-3B5AFA646589}" type="datetimeFigureOut">
               <a:rPr lang="en-US" smtClean="0"/>
-              <a:t>9/26/2026</a:t>
+              <a:t>10/2/2026</a:t>
             </a:fld>
             <a:endParaRPr lang="en-US"/>
           </a:p>
@@ -2905,7 +2929,7 @@
           <a:p>
             <a:fld id="{32EB0E7F-F65E-4199-9595-3B5AFA646589}" type="datetimeFigureOut">
               <a:rPr lang="en-US" smtClean="0"/>
-              <a:t>9/26/2026</a:t>
+              <a:t>10/2/2026</a:t>
             </a:fld>
             <a:endParaRPr lang="en-US"/>
           </a:p>
@@ -3146,7 +3170,7 @@
           <a:p>
             <a:fld id="{32EB0E7F-F65E-4199-9595-3B5AFA646589}" type="datetimeFigureOut">
               <a:rPr lang="en-US" smtClean="0"/>
-              <a:t>9/26/2026</a:t>
+              <a:t>10/2/2026</a:t>
             </a:fld>
             <a:endParaRPr lang="en-US"/>
           </a:p>
@@ -3638,6 +3662,199 @@
 </p:sld>
 </file>
 
+<file path=ppt/slides/slide10.xml><?xml version="1.0" encoding="utf-8"?>
+<p:sld xmlns:a="http://schemas.openxmlformats.org/drawingml/2006/main" xmlns:r="http://schemas.openxmlformats.org/officeDocument/2006/relationships" xmlns:p="http://schemas.openxmlformats.org/presentationml/2006/main">
+  <p:cSld>
+    <p:spTree>
+      <p:nvGrpSpPr>
+        <p:cNvPr id="1" name=""/>
+        <p:cNvGrpSpPr/>
+        <p:nvPr/>
+      </p:nvGrpSpPr>
+      <p:grpSpPr>
+        <a:xfrm>
+          <a:off x="0" y="0"/>
+          <a:ext cx="0" cy="0"/>
+          <a:chOff x="0" y="0"/>
+          <a:chExt cx="0" cy="0"/>
+        </a:xfrm>
+      </p:grpSpPr>
+      <p:sp>
+        <p:nvSpPr>
+          <p:cNvPr id="2" name="Title 1">
+            <a:extLst>
+              <a:ext uri="{FF2B5EF4-FFF2-40B4-BE49-F238E27FC236}">
+                <a16:creationId xmlns:a16="http://schemas.microsoft.com/office/drawing/2014/main" id="{9BC690AF-0F05-830A-0ED8-ED12CF3E4ACD}"/>
+              </a:ext>
+            </a:extLst>
+          </p:cNvPr>
+          <p:cNvSpPr>
+            <a:spLocks noGrp="1"/>
+          </p:cNvSpPr>
+          <p:nvPr>
+            <p:ph type="title"/>
+          </p:nvPr>
+        </p:nvSpPr>
+        <p:spPr/>
+        <p:txBody>
+          <a:bodyPr/>
+          <a:lstStyle/>
+          <a:p>
+            <a:r>
+              <a:rPr lang="en-US" dirty="0"/>
+              <a:t>Glossary</a:t>
+            </a:r>
+          </a:p>
+        </p:txBody>
+      </p:sp>
+      <p:sp>
+        <p:nvSpPr>
+          <p:cNvPr id="3" name="Content Placeholder 2">
+            <a:extLst>
+              <a:ext uri="{FF2B5EF4-FFF2-40B4-BE49-F238E27FC236}">
+                <a16:creationId xmlns:a16="http://schemas.microsoft.com/office/drawing/2014/main" id="{297F69B7-E451-A515-BAA9-AD4D28EC0D9A}"/>
+              </a:ext>
+            </a:extLst>
+          </p:cNvPr>
+          <p:cNvSpPr>
+            <a:spLocks noGrp="1"/>
+          </p:cNvSpPr>
+          <p:nvPr>
+            <p:ph idx="1"/>
+          </p:nvPr>
+        </p:nvSpPr>
+        <p:spPr/>
+        <p:txBody>
+          <a:bodyPr>
+            <a:normAutofit fontScale="70000" lnSpcReduction="20000"/>
+          </a:bodyPr>
+          <a:lstStyle/>
+          <a:p>
+            <a:r>
+              <a:rPr lang="en-US" i="1" dirty="0"/>
+              <a:t>Material</a:t>
+            </a:r>
+            <a:r>
+              <a:rPr lang="en-US" dirty="0"/>
+              <a:t>: The full body of the text the user is trying to recall</a:t>
+            </a:r>
+          </a:p>
+          <a:p>
+            <a:r>
+              <a:rPr lang="en-US" i="1" dirty="0"/>
+              <a:t>Sample</a:t>
+            </a:r>
+            <a:r>
+              <a:rPr lang="en-US" dirty="0"/>
+              <a:t>: The portion of the text the user quizzes themselves on</a:t>
+            </a:r>
+            <a:endParaRPr lang="en-US" i="1" dirty="0"/>
+          </a:p>
+          <a:p>
+            <a:r>
+              <a:rPr lang="en-US" i="1" dirty="0"/>
+              <a:t>Content</a:t>
+            </a:r>
+            <a:r>
+              <a:rPr lang="en-US" dirty="0"/>
+              <a:t>: The part of the material that is showing on a particular screen</a:t>
+            </a:r>
+          </a:p>
+          <a:p>
+            <a:r>
+              <a:rPr lang="en-US" i="1" dirty="0"/>
+              <a:t>Screen</a:t>
+            </a:r>
+            <a:r>
+              <a:rPr lang="en-US" dirty="0"/>
+              <a:t>: A particular window of the app. A Game Screen has a score bar and Content.</a:t>
+            </a:r>
+          </a:p>
+          <a:p>
+            <a:r>
+              <a:rPr lang="en-US" i="1" dirty="0"/>
+              <a:t>Game</a:t>
+            </a:r>
+            <a:r>
+              <a:rPr lang="en-US" dirty="0"/>
+              <a:t>: A set of Screens that, when put together, have a Sample as their Content.</a:t>
+            </a:r>
+            <a:endParaRPr lang="en-US" i="1" dirty="0"/>
+          </a:p>
+          <a:p>
+            <a:r>
+              <a:rPr lang="en-US" i="1" dirty="0"/>
+              <a:t>Sequence</a:t>
+            </a:r>
+            <a:r>
+              <a:rPr lang="en-US" dirty="0"/>
+              <a:t>: The order (e.g., random, sequential) in which a Sample is presented to the user in a Game.</a:t>
+            </a:r>
+            <a:endParaRPr lang="en-US" i="1" dirty="0"/>
+          </a:p>
+          <a:p>
+            <a:r>
+              <a:rPr lang="en-US" i="1" dirty="0"/>
+              <a:t>Attempt</a:t>
+            </a:r>
+            <a:r>
+              <a:rPr lang="en-US" dirty="0"/>
+              <a:t>: When a user tries to recall a word, may be right or wrong</a:t>
+            </a:r>
+          </a:p>
+          <a:p>
+            <a:r>
+              <a:rPr lang="en-US" i="1" dirty="0"/>
+              <a:t>Max Attempts</a:t>
+            </a:r>
+            <a:r>
+              <a:rPr lang="en-US" dirty="0"/>
+              <a:t>: How many </a:t>
+            </a:r>
+            <a:r>
+              <a:rPr lang="en-US" b="1" dirty="0"/>
+              <a:t>wrong</a:t>
+            </a:r>
+            <a:r>
+              <a:rPr lang="en-US" dirty="0"/>
+              <a:t> attempts a user may incur before moving to the next word</a:t>
+            </a:r>
+          </a:p>
+          <a:p>
+            <a:r>
+              <a:rPr lang="en-US" i="1" dirty="0"/>
+              <a:t>Mode/minigame</a:t>
+            </a:r>
+            <a:r>
+              <a:rPr lang="en-US" dirty="0"/>
+              <a:t>: A way to play BMC; each one tests user understanding in a different way</a:t>
+            </a:r>
+          </a:p>
+          <a:p>
+            <a:r>
+              <a:rPr lang="en-US" i="1" dirty="0"/>
+              <a:t>Playthrough</a:t>
+            </a:r>
+            <a:r>
+              <a:rPr lang="en-US" dirty="0"/>
+              <a:t>: All the screens (from start to score screen) of a particular minigame put together</a:t>
+            </a:r>
+          </a:p>
+        </p:txBody>
+      </p:sp>
+    </p:spTree>
+    <p:extLst>
+      <p:ext uri="{BB962C8B-B14F-4D97-AF65-F5344CB8AC3E}">
+        <p14:creationId xmlns:p14="http://schemas.microsoft.com/office/powerpoint/2010/main" val="1493022053"/>
+      </p:ext>
+    </p:extLst>
+  </p:cSld>
+  <p:clrMapOvr>
+    <a:masterClrMapping/>
+  </p:clrMapOvr>
+</p:sld>
+</file>
+
 <file path=ppt/slides/slide2.xml><?xml version="1.0" encoding="utf-8"?>
 <p:sld xmlns:a="http://schemas.openxmlformats.org/drawingml/2006/main" xmlns:r="http://schemas.openxmlformats.org/officeDocument/2006/relationships" xmlns:p="http://schemas.openxmlformats.org/presentationml/2006/main">
   <p:cSld>
@@ -4433,7 +4650,7 @@
           <a:lstStyle/>
           <a:p>
             <a:r>
-              <a:rPr lang="en-US"/>
+              <a:rPr lang="en-US" dirty="0"/>
               <a:t>Screens for typical use</a:t>
             </a:r>
           </a:p>
@@ -4443,7 +4660,7 @@
               <a:buAutoNum type="arabicPeriod"/>
             </a:pPr>
             <a:r>
-              <a:rPr lang="en-US"/>
+              <a:rPr lang="en-US" dirty="0"/>
               <a:t>Choose Material</a:t>
             </a:r>
           </a:p>
@@ -4453,7 +4670,7 @@
               <a:buAutoNum type="arabicPeriod"/>
             </a:pPr>
             <a:r>
-              <a:rPr lang="en-US"/>
+              <a:rPr lang="en-US" dirty="0"/>
               <a:t>Settings (Agree to Defaults)</a:t>
             </a:r>
           </a:p>
@@ -4463,7 +4680,7 @@
               <a:buAutoNum type="arabicPeriod"/>
             </a:pPr>
             <a:r>
-              <a:rPr lang="en-US"/>
+              <a:rPr lang="en-US" dirty="0"/>
               <a:t>Choose minigame/mode</a:t>
             </a:r>
           </a:p>
@@ -4473,9 +4690,14 @@
               <a:buAutoNum type="arabicPeriod"/>
             </a:pPr>
             <a:r>
-              <a:rPr lang="en-US"/>
-              <a:t>Play game / start screen / Screen i</a:t>
-            </a:r>
+              <a:rPr lang="en-US" dirty="0"/>
+              <a:t>Play game / start screen / Screen </a:t>
+            </a:r>
+            <a:r>
+              <a:rPr lang="en-US" dirty="0" err="1"/>
+              <a:t>i</a:t>
+            </a:r>
+            <a:endParaRPr lang="en-US" dirty="0"/>
           </a:p>
           <a:p>
             <a:pPr marL="914400" lvl="1" indent="-457200">
@@ -4483,7 +4705,7 @@
               <a:buAutoNum type="arabicPeriod"/>
             </a:pPr>
             <a:r>
-              <a:rPr lang="en-US"/>
+              <a:rPr lang="en-US" dirty="0"/>
               <a:t>Pause Screen?</a:t>
             </a:r>
           </a:p>
@@ -4493,7 +4715,7 @@
               <a:buAutoNum type="arabicPeriod"/>
             </a:pPr>
             <a:r>
-              <a:rPr lang="en-US"/>
+              <a:rPr lang="en-US" dirty="0"/>
               <a:t>Next Screen / Screen i+1</a:t>
             </a:r>
           </a:p>
@@ -4503,10 +4725,19 @@
               <a:buAutoNum type="arabicPeriod"/>
             </a:pPr>
             <a:r>
-              <a:rPr lang="en-US"/>
-              <a:t>End Screen (Game Over screen?)</a:t>
-            </a:r>
-            <a:endParaRPr lang="en-US" dirty="0"/>
+              <a:rPr lang="en-US" dirty="0"/>
+              <a:t>End Screen (Game Over screen?) </a:t>
+            </a:r>
+          </a:p>
+          <a:p>
+            <a:pPr marL="914400" lvl="1" indent="-457200">
+              <a:buFont typeface="+mj-lt"/>
+              <a:buAutoNum type="arabicPeriod"/>
+            </a:pPr>
+            <a:r>
+              <a:rPr lang="en-US" dirty="0"/>
+              <a:t>Back to Minigame screen?</a:t>
+            </a:r>
           </a:p>
         </p:txBody>
       </p:sp>

</xml_diff>